<commit_message>
Restore editable PowerPoint decks with separate text boxes.
Add a blank bracket template and regenerate the example deck so every field is clickable in PowerPoint or Google Slides. Remove the non-editable PDF/picture export.

Co-authored-by: jackiechowstockanalysis <jackiechowstockanalysis@gmail.com>
</commit_message>
<xml_diff>
--- a/playbooks/hq-field-progress-slides.pptx
+++ b/playbooks/hq-field-progress-slides.pptx
@@ -11,7 +11,7 @@
     <p:sldId id="259" r:id="rId10"/>
     <p:sldId id="260" r:id="rId11"/>
   </p:sldIdLst>
-  <p:sldSz cx="12191999" cy="6858000" type="screen4x3"/>
+  <p:sldSz cx="12191695" cy="6858000" type="screen4x3"/>
   <p:notesSz cx="6858000" cy="9144000"/>
   <p:defaultTextStyle>
     <a:defPPr>
@@ -3092,30 +3092,1022 @@
         <p:nvPr/>
       </p:nvGrpSpPr>
       <p:grpSpPr/>
-      <p:pic>
-        <p:nvPicPr>
-          <p:cNvPr id="2" name="Picture 1" descr="example-1.png"/>
-          <p:cNvPicPr>
-            <a:picLocks noChangeAspect="1"/>
-          </p:cNvPicPr>
-          <p:nvPr/>
-        </p:nvPicPr>
-        <p:blipFill>
-          <a:blip r:embed="rId2"/>
-          <a:stretch>
-            <a:fillRect/>
-          </a:stretch>
-        </p:blipFill>
+      <p:sp>
+        <p:nvSpPr>
+          <p:cNvPr id="2" name="bg"/>
+          <p:cNvSpPr/>
+          <p:nvPr/>
+        </p:nvSpPr>
         <p:spPr>
           <a:xfrm>
             <a:off x="0" y="0"/>
-            <a:ext cx="12191999" cy="6858000"/>
+            <a:ext cx="12191695" cy="6858000"/>
           </a:xfrm>
           <a:prstGeom prst="rect">
             <a:avLst/>
           </a:prstGeom>
-        </p:spPr>
-      </p:pic>
+          <a:solidFill>
+            <a:srgbClr val="F4F1EA"/>
+          </a:solidFill>
+          <a:ln>
+            <a:noFill/>
+          </a:ln>
+        </p:spPr>
+        <p:style>
+          <a:lnRef idx="1">
+            <a:schemeClr val="accent1"/>
+          </a:lnRef>
+          <a:fillRef idx="3">
+            <a:schemeClr val="accent1"/>
+          </a:fillRef>
+          <a:effectRef idx="2">
+            <a:schemeClr val="accent1"/>
+          </a:effectRef>
+          <a:fontRef idx="minor">
+            <a:schemeClr val="lt1"/>
+          </a:fontRef>
+        </p:style>
+        <p:txBody>
+          <a:bodyPr rtlCol="0" anchor="ctr"/>
+          <a:lstStyle/>
+          <a:p>
+            <a:pPr algn="ctr"/>
+          </a:p>
+        </p:txBody>
+      </p:sp>
+      <p:sp>
+        <p:nvSpPr>
+          <p:cNvPr id="3" name="hdr_left"/>
+          <p:cNvSpPr txBox="1"/>
+          <p:nvPr/>
+        </p:nvSpPr>
+        <p:spPr>
+          <a:xfrm>
+            <a:off x="411480" y="128016"/>
+            <a:ext cx="6400800" cy="274320"/>
+          </a:xfrm>
+          <a:prstGeom prst="rect">
+            <a:avLst/>
+          </a:prstGeom>
+          <a:noFill/>
+        </p:spPr>
+        <p:txBody>
+          <a:bodyPr wrap="square" anchor="t">
+            <a:spAutoFit/>
+          </a:bodyPr>
+          <a:lstStyle/>
+          <a:p>
+            <a:pPr>
+              <a:spcAft>
+                <a:spcPts val="300"/>
+              </a:spcAft>
+            </a:pPr>
+            <a:r>
+              <a:rPr sz="1100" b="1">
+                <a:solidFill>
+                  <a:srgbClr val="0E2744"/>
+                </a:solidFill>
+                <a:latin typeface="Calibri"/>
+              </a:rPr>
+              <a:t>BESREMi | HK PV | PM field pack</a:t>
+            </a:r>
+          </a:p>
+        </p:txBody>
+      </p:sp>
+      <p:sp>
+        <p:nvSpPr>
+          <p:cNvPr id="4" name="hdr_right"/>
+          <p:cNvSpPr txBox="1"/>
+          <p:nvPr/>
+        </p:nvSpPr>
+        <p:spPr>
+          <a:xfrm>
+            <a:off x="6583680" y="128016"/>
+            <a:ext cx="5212080" cy="274320"/>
+          </a:xfrm>
+          <a:prstGeom prst="rect">
+            <a:avLst/>
+          </a:prstGeom>
+          <a:noFill/>
+        </p:spPr>
+        <p:txBody>
+          <a:bodyPr wrap="square" anchor="t">
+            <a:spAutoFit/>
+          </a:bodyPr>
+          <a:lstStyle/>
+          <a:p>
+            <a:pPr algn="r">
+              <a:spcAft>
+                <a:spcPts val="300"/>
+              </a:spcAft>
+            </a:pPr>
+            <a:r>
+              <a:rPr sz="1100" b="1">
+                <a:solidFill>
+                  <a:srgbClr val="5B6B7C"/>
+                </a:solidFill>
+                <a:latin typeface="Calibri"/>
+              </a:rPr>
+              <a:t>Biweekly | [dates] | Mid | Internal | De-identified</a:t>
+            </a:r>
+          </a:p>
+        </p:txBody>
+      </p:sp>
+      <p:sp>
+        <p:nvSpPr>
+          <p:cNvPr id="5" name="flag_bg"/>
+          <p:cNvSpPr/>
+          <p:nvPr/>
+        </p:nvSpPr>
+        <p:spPr>
+          <a:xfrm>
+            <a:off x="411480" y="384048"/>
+            <a:ext cx="6583680" cy="310896"/>
+          </a:xfrm>
+          <a:prstGeom prst="roundRect">
+            <a:avLst/>
+          </a:prstGeom>
+          <a:solidFill>
+            <a:srgbClr val="F8EED3"/>
+          </a:solidFill>
+          <a:ln>
+            <a:noFill/>
+          </a:ln>
+        </p:spPr>
+        <p:style>
+          <a:lnRef idx="1">
+            <a:schemeClr val="accent1"/>
+          </a:lnRef>
+          <a:fillRef idx="3">
+            <a:schemeClr val="accent1"/>
+          </a:fillRef>
+          <a:effectRef idx="2">
+            <a:schemeClr val="accent1"/>
+          </a:effectRef>
+          <a:fontRef idx="minor">
+            <a:schemeClr val="lt1"/>
+          </a:fontRef>
+        </p:style>
+        <p:txBody>
+          <a:bodyPr rtlCol="0" anchor="ctr"/>
+          <a:lstStyle/>
+          <a:p>
+            <a:pPr algn="ctr"/>
+          </a:p>
+        </p:txBody>
+      </p:sp>
+      <p:sp>
+        <p:nvSpPr>
+          <p:cNvPr id="6" name="flag"/>
+          <p:cNvSpPr txBox="1"/>
+          <p:nvPr/>
+        </p:nvSpPr>
+        <p:spPr>
+          <a:xfrm>
+            <a:off x="521208" y="420624"/>
+            <a:ext cx="6309360" cy="237744"/>
+          </a:xfrm>
+          <a:prstGeom prst="rect">
+            <a:avLst/>
+          </a:prstGeom>
+          <a:noFill/>
+        </p:spPr>
+        <p:txBody>
+          <a:bodyPr wrap="square" anchor="t">
+            <a:spAutoFit/>
+          </a:bodyPr>
+          <a:lstStyle/>
+          <a:p>
+            <a:pPr>
+              <a:spcAft>
+                <a:spcPts val="300"/>
+              </a:spcAft>
+            </a:pPr>
+            <a:r>
+              <a:rPr sz="1100" b="1">
+                <a:solidFill>
+                  <a:srgbClr val="6B4E00"/>
+                </a:solidFill>
+                <a:latin typeface="Calibri"/>
+              </a:rPr>
+              <a:t>SAMPLE - replace before sending to HQ</a:t>
+            </a:r>
+          </a:p>
+        </p:txBody>
+      </p:sp>
+      <p:sp>
+        <p:nvSpPr>
+          <p:cNvPr id="7" name="kicker"/>
+          <p:cNvSpPr txBox="1"/>
+          <p:nvPr/>
+        </p:nvSpPr>
+        <p:spPr>
+          <a:xfrm>
+            <a:off x="411480" y="749808"/>
+            <a:ext cx="11338560" cy="237744"/>
+          </a:xfrm>
+          <a:prstGeom prst="rect">
+            <a:avLst/>
+          </a:prstGeom>
+          <a:noFill/>
+        </p:spPr>
+        <p:txBody>
+          <a:bodyPr wrap="square" anchor="t">
+            <a:spAutoFit/>
+          </a:bodyPr>
+          <a:lstStyle/>
+          <a:p>
+            <a:pPr>
+              <a:spcAft>
+                <a:spcPts val="300"/>
+              </a:spcAft>
+            </a:pPr>
+            <a:r>
+              <a:rPr sz="1100" b="1">
+                <a:solidFill>
+                  <a:srgbClr val="1B7A6E"/>
+                </a:solidFill>
+                <a:latin typeface="Calibri"/>
+              </a:rPr>
+              <a:t>THE ASK - FIRST 30 SECONDS</a:t>
+            </a:r>
+          </a:p>
+        </p:txBody>
+      </p:sp>
+      <p:sp>
+        <p:nvSpPr>
+          <p:cNvPr id="8" name="ask_bg"/>
+          <p:cNvSpPr/>
+          <p:nvPr/>
+        </p:nvSpPr>
+        <p:spPr>
+          <a:xfrm>
+            <a:off x="411480" y="1024128"/>
+            <a:ext cx="11365992" cy="1417320"/>
+          </a:xfrm>
+          <a:prstGeom prst="roundRect">
+            <a:avLst/>
+          </a:prstGeom>
+          <a:solidFill>
+            <a:srgbClr val="0E2744"/>
+          </a:solidFill>
+          <a:ln>
+            <a:noFill/>
+          </a:ln>
+        </p:spPr>
+        <p:style>
+          <a:lnRef idx="1">
+            <a:schemeClr val="accent1"/>
+          </a:lnRef>
+          <a:fillRef idx="3">
+            <a:schemeClr val="accent1"/>
+          </a:fillRef>
+          <a:effectRef idx="2">
+            <a:schemeClr val="accent1"/>
+          </a:effectRef>
+          <a:fontRef idx="minor">
+            <a:schemeClr val="lt1"/>
+          </a:fontRef>
+        </p:style>
+        <p:txBody>
+          <a:bodyPr rtlCol="0" anchor="ctr"/>
+          <a:lstStyle/>
+          <a:p>
+            <a:pPr algn="ctr"/>
+          </a:p>
+        </p:txBody>
+      </p:sp>
+      <p:sp>
+        <p:nvSpPr>
+          <p:cNvPr id="9" name="ask_label"/>
+          <p:cNvSpPr txBox="1"/>
+          <p:nvPr/>
+        </p:nvSpPr>
+        <p:spPr>
+          <a:xfrm>
+            <a:off x="594360" y="1097280"/>
+            <a:ext cx="10972800" cy="219456"/>
+          </a:xfrm>
+          <a:prstGeom prst="rect">
+            <a:avLst/>
+          </a:prstGeom>
+          <a:noFill/>
+        </p:spPr>
+        <p:txBody>
+          <a:bodyPr wrap="square" anchor="t">
+            <a:spAutoFit/>
+          </a:bodyPr>
+          <a:lstStyle/>
+          <a:p>
+            <a:pPr>
+              <a:spcAft>
+                <a:spcPts val="300"/>
+              </a:spcAft>
+            </a:pPr>
+            <a:r>
+              <a:rPr sz="1100" b="1">
+                <a:solidFill>
+                  <a:srgbClr val="B8860B"/>
+                </a:solidFill>
+                <a:latin typeface="Calibri"/>
+              </a:rPr>
+              <a:t>HQ SHOULD DO THIS</a:t>
+            </a:r>
+          </a:p>
+        </p:txBody>
+      </p:sp>
+      <p:sp>
+        <p:nvSpPr>
+          <p:cNvPr id="10" name="ask"/>
+          <p:cNvSpPr txBox="1"/>
+          <p:nvPr/>
+        </p:nvSpPr>
+        <p:spPr>
+          <a:xfrm>
+            <a:off x="594360" y="1353312"/>
+            <a:ext cx="10972800" cy="1005840"/>
+          </a:xfrm>
+          <a:prstGeom prst="rect">
+            <a:avLst/>
+          </a:prstGeom>
+          <a:noFill/>
+        </p:spPr>
+        <p:txBody>
+          <a:bodyPr wrap="square" anchor="t">
+            <a:spAutoFit/>
+          </a:bodyPr>
+          <a:lstStyle/>
+          <a:p>
+            <a:pPr>
+              <a:spcAft>
+                <a:spcPts val="300"/>
+              </a:spcAft>
+            </a:pPr>
+            <a:r>
+              <a:rPr sz="2200" b="1">
+                <a:solidFill>
+                  <a:srgbClr val="FFFCF7"/>
+                </a:solidFill>
+                <a:latin typeface="Calibri"/>
+              </a:rPr>
+              <a:t>Concentrate the next two weeks on initiation barriers in priority private accounts. Do not treat call volume as the progress metric.</a:t>
+            </a:r>
+          </a:p>
+        </p:txBody>
+      </p:sp>
+      <p:sp>
+        <p:nvSpPr>
+          <p:cNvPr id="11" name="why_bg"/>
+          <p:cNvSpPr/>
+          <p:nvPr/>
+        </p:nvSpPr>
+        <p:spPr>
+          <a:xfrm>
+            <a:off x="411480" y="2606040"/>
+            <a:ext cx="5532120" cy="1783080"/>
+          </a:xfrm>
+          <a:prstGeom prst="roundRect">
+            <a:avLst/>
+          </a:prstGeom>
+          <a:solidFill>
+            <a:srgbClr val="FFFFFF"/>
+          </a:solidFill>
+          <a:ln>
+            <a:solidFill>
+              <a:srgbClr val="D8D2C6"/>
+            </a:solidFill>
+          </a:ln>
+        </p:spPr>
+        <p:style>
+          <a:lnRef idx="1">
+            <a:schemeClr val="accent1"/>
+          </a:lnRef>
+          <a:fillRef idx="3">
+            <a:schemeClr val="accent1"/>
+          </a:fillRef>
+          <a:effectRef idx="2">
+            <a:schemeClr val="accent1"/>
+          </a:effectRef>
+          <a:fontRef idx="minor">
+            <a:schemeClr val="lt1"/>
+          </a:fontRef>
+        </p:style>
+        <p:txBody>
+          <a:bodyPr rtlCol="0" anchor="ctr"/>
+          <a:lstStyle/>
+          <a:p>
+            <a:pPr algn="ctr"/>
+          </a:p>
+        </p:txBody>
+      </p:sp>
+      <p:sp>
+        <p:nvSpPr>
+          <p:cNvPr id="12" name="rec_bg"/>
+          <p:cNvSpPr/>
+          <p:nvPr/>
+        </p:nvSpPr>
+        <p:spPr>
+          <a:xfrm>
+            <a:off x="6245352" y="2606040"/>
+            <a:ext cx="5532120" cy="1783080"/>
+          </a:xfrm>
+          <a:prstGeom prst="roundRect">
+            <a:avLst/>
+          </a:prstGeom>
+          <a:solidFill>
+            <a:srgbClr val="FFFFFF"/>
+          </a:solidFill>
+          <a:ln>
+            <a:solidFill>
+              <a:srgbClr val="D8D2C6"/>
+            </a:solidFill>
+          </a:ln>
+        </p:spPr>
+        <p:style>
+          <a:lnRef idx="1">
+            <a:schemeClr val="accent1"/>
+          </a:lnRef>
+          <a:fillRef idx="3">
+            <a:schemeClr val="accent1"/>
+          </a:fillRef>
+          <a:effectRef idx="2">
+            <a:schemeClr val="accent1"/>
+          </a:effectRef>
+          <a:fontRef idx="minor">
+            <a:schemeClr val="lt1"/>
+          </a:fontRef>
+        </p:style>
+        <p:txBody>
+          <a:bodyPr rtlCol="0" anchor="ctr"/>
+          <a:lstStyle/>
+          <a:p>
+            <a:pPr algn="ctr"/>
+          </a:p>
+        </p:txBody>
+      </p:sp>
+      <p:sp>
+        <p:nvSpPr>
+          <p:cNvPr id="13" name="why_now"/>
+          <p:cNvSpPr txBox="1"/>
+          <p:nvPr/>
+        </p:nvSpPr>
+        <p:spPr>
+          <a:xfrm>
+            <a:off x="557784" y="2697480"/>
+            <a:ext cx="5257800" cy="1600200"/>
+          </a:xfrm>
+          <a:prstGeom prst="rect">
+            <a:avLst/>
+          </a:prstGeom>
+          <a:noFill/>
+        </p:spPr>
+        <p:txBody>
+          <a:bodyPr wrap="square" anchor="t">
+            <a:spAutoFit/>
+          </a:bodyPr>
+          <a:lstStyle/>
+          <a:p>
+            <a:pPr>
+              <a:spcAft>
+                <a:spcPts val="300"/>
+              </a:spcAft>
+            </a:pPr>
+            <a:r>
+              <a:rPr sz="1100" b="1">
+                <a:solidFill>
+                  <a:srgbClr val="5B6B7C"/>
+                </a:solidFill>
+                <a:latin typeface="Calibri"/>
+              </a:rPr>
+              <a:t>WHY NOW</a:t>
+            </a:r>
+          </a:p>
+          <a:p>
+            <a:pPr>
+              <a:spcAft>
+                <a:spcPts val="300"/>
+              </a:spcAft>
+            </a:pPr>
+            <a:r>
+              <a:rPr sz="1600" b="0">
+                <a:solidFill>
+                  <a:srgbClr val="1C2A3A"/>
+                </a:solidFill>
+                <a:latin typeface="Calibri"/>
+              </a:rPr>
+              <a:t>Private-sector PSP expiry (end-2026) is already changing close conversations. Formulary packaging needs field themes, not visit counts, while the evidence window is still open.</a:t>
+            </a:r>
+          </a:p>
+        </p:txBody>
+      </p:sp>
+      <p:sp>
+        <p:nvSpPr>
+          <p:cNvPr id="14" name="recommendation"/>
+          <p:cNvSpPr txBox="1"/>
+          <p:nvPr/>
+        </p:nvSpPr>
+        <p:spPr>
+          <a:xfrm>
+            <a:off x="6391656" y="2697480"/>
+            <a:ext cx="5257800" cy="1600200"/>
+          </a:xfrm>
+          <a:prstGeom prst="rect">
+            <a:avLst/>
+          </a:prstGeom>
+          <a:noFill/>
+        </p:spPr>
+        <p:txBody>
+          <a:bodyPr wrap="square" anchor="t">
+            <a:spAutoFit/>
+          </a:bodyPr>
+          <a:lstStyle/>
+          <a:p>
+            <a:pPr>
+              <a:spcAft>
+                <a:spcPts val="300"/>
+              </a:spcAft>
+            </a:pPr>
+            <a:r>
+              <a:rPr sz="1100" b="1">
+                <a:solidFill>
+                  <a:srgbClr val="5B6B7C"/>
+                </a:solidFill>
+                <a:latin typeface="Calibri"/>
+              </a:rPr>
+              <a:t>RECOMMENDATION</a:t>
+            </a:r>
+          </a:p>
+          <a:p>
+            <a:pPr>
+              <a:spcAft>
+                <a:spcPts val="300"/>
+              </a:spcAft>
+            </a:pPr>
+            <a:r>
+              <a:rPr sz="1600" b="0">
+                <a:solidFill>
+                  <a:srgbClr val="1C2A3A"/>
+                </a:solidFill>
+                <a:latin typeface="Calibri"/>
+              </a:rPr>
+              <a:t>Do: report 3 conversion signals mapped to uptake / formulary / compliance. Do not: send trip logs, named HCPs, or CRM dumps.</a:t>
+            </a:r>
+          </a:p>
+        </p:txBody>
+      </p:sp>
+      <p:sp>
+        <p:nvSpPr>
+          <p:cNvPr id="15" name="snap_bg_1"/>
+          <p:cNvSpPr/>
+          <p:nvPr/>
+        </p:nvSpPr>
+        <p:spPr>
+          <a:xfrm>
+            <a:off x="411480" y="4526280"/>
+            <a:ext cx="3520440" cy="960120"/>
+          </a:xfrm>
+          <a:prstGeom prst="roundRect">
+            <a:avLst/>
+          </a:prstGeom>
+          <a:solidFill>
+            <a:srgbClr val="FFFFFF"/>
+          </a:solidFill>
+          <a:ln>
+            <a:solidFill>
+              <a:srgbClr val="D8D2C6"/>
+            </a:solidFill>
+          </a:ln>
+        </p:spPr>
+        <p:style>
+          <a:lnRef idx="1">
+            <a:schemeClr val="accent1"/>
+          </a:lnRef>
+          <a:fillRef idx="3">
+            <a:schemeClr val="accent1"/>
+          </a:fillRef>
+          <a:effectRef idx="2">
+            <a:schemeClr val="accent1"/>
+          </a:effectRef>
+          <a:fontRef idx="minor">
+            <a:schemeClr val="lt1"/>
+          </a:fontRef>
+        </p:style>
+        <p:txBody>
+          <a:bodyPr rtlCol="0" anchor="ctr"/>
+          <a:lstStyle/>
+          <a:p>
+            <a:pPr algn="ctr"/>
+          </a:p>
+        </p:txBody>
+      </p:sp>
+      <p:sp>
+        <p:nvSpPr>
+          <p:cNvPr id="16" name="snap_1"/>
+          <p:cNvSpPr txBox="1"/>
+          <p:nvPr/>
+        </p:nvSpPr>
+        <p:spPr>
+          <a:xfrm>
+            <a:off x="539496" y="4590288"/>
+            <a:ext cx="3246120" cy="822960"/>
+          </a:xfrm>
+          <a:prstGeom prst="rect">
+            <a:avLst/>
+          </a:prstGeom>
+          <a:noFill/>
+        </p:spPr>
+        <p:txBody>
+          <a:bodyPr wrap="square" anchor="t">
+            <a:spAutoFit/>
+          </a:bodyPr>
+          <a:lstStyle/>
+          <a:p>
+            <a:pPr>
+              <a:spcAft>
+                <a:spcPts val="300"/>
+              </a:spcAft>
+            </a:pPr>
+            <a:r>
+              <a:rPr sz="1000" b="1">
+                <a:solidFill>
+                  <a:srgbClr val="5B6B7C"/>
+                </a:solidFill>
+                <a:latin typeface="Calibri"/>
+              </a:rPr>
+              <a:t>FORMULARY THIS CYCLE</a:t>
+            </a:r>
+          </a:p>
+          <a:p>
+            <a:pPr>
+              <a:spcAft>
+                <a:spcPts val="300"/>
+              </a:spcAft>
+            </a:pPr>
+            <a:r>
+              <a:rPr sz="1300" b="1">
+                <a:solidFill>
+                  <a:srgbClr val="0E2744"/>
+                </a:solidFill>
+                <a:latin typeface="Calibri"/>
+              </a:rPr>
+              <a:t>No change to dossier - themes usable, no new unlock</a:t>
+            </a:r>
+          </a:p>
+        </p:txBody>
+      </p:sp>
+      <p:sp>
+        <p:nvSpPr>
+          <p:cNvPr id="17" name="snap_bg_2"/>
+          <p:cNvSpPr/>
+          <p:nvPr/>
+        </p:nvSpPr>
+        <p:spPr>
+          <a:xfrm>
+            <a:off x="4343400" y="4526280"/>
+            <a:ext cx="3520440" cy="960120"/>
+          </a:xfrm>
+          <a:prstGeom prst="roundRect">
+            <a:avLst/>
+          </a:prstGeom>
+          <a:solidFill>
+            <a:srgbClr val="FFFFFF"/>
+          </a:solidFill>
+          <a:ln>
+            <a:solidFill>
+              <a:srgbClr val="D8D2C6"/>
+            </a:solidFill>
+          </a:ln>
+        </p:spPr>
+        <p:style>
+          <a:lnRef idx="1">
+            <a:schemeClr val="accent1"/>
+          </a:lnRef>
+          <a:fillRef idx="3">
+            <a:schemeClr val="accent1"/>
+          </a:fillRef>
+          <a:effectRef idx="2">
+            <a:schemeClr val="accent1"/>
+          </a:effectRef>
+          <a:fontRef idx="minor">
+            <a:schemeClr val="lt1"/>
+          </a:fontRef>
+        </p:style>
+        <p:txBody>
+          <a:bodyPr rtlCol="0" anchor="ctr"/>
+          <a:lstStyle/>
+          <a:p>
+            <a:pPr algn="ctr"/>
+          </a:p>
+        </p:txBody>
+      </p:sp>
+      <p:sp>
+        <p:nvSpPr>
+          <p:cNvPr id="18" name="snap_2"/>
+          <p:cNvSpPr txBox="1"/>
+          <p:nvPr/>
+        </p:nvSpPr>
+        <p:spPr>
+          <a:xfrm>
+            <a:off x="4471416" y="4590288"/>
+            <a:ext cx="3246120" cy="822960"/>
+          </a:xfrm>
+          <a:prstGeom prst="rect">
+            <a:avLst/>
+          </a:prstGeom>
+          <a:noFill/>
+        </p:spPr>
+        <p:txBody>
+          <a:bodyPr wrap="square" anchor="t">
+            <a:spAutoFit/>
+          </a:bodyPr>
+          <a:lstStyle/>
+          <a:p>
+            <a:pPr>
+              <a:spcAft>
+                <a:spcPts val="300"/>
+              </a:spcAft>
+            </a:pPr>
+            <a:r>
+              <a:rPr sz="1000" b="1">
+                <a:solidFill>
+                  <a:srgbClr val="5B6B7C"/>
+                </a:solidFill>
+                <a:latin typeface="Calibri"/>
+              </a:rPr>
+              <a:t>PSP IN PLAY</a:t>
+            </a:r>
+          </a:p>
+          <a:p>
+            <a:pPr>
+              <a:spcAft>
+                <a:spcPts val="300"/>
+              </a:spcAft>
+            </a:pPr>
+            <a:r>
+              <a:rPr sz="1300" b="1">
+                <a:solidFill>
+                  <a:srgbClr val="0E2744"/>
+                </a:solidFill>
+                <a:latin typeface="Calibri"/>
+              </a:rPr>
+              <a:t>Base Case + Private Sector (expires end-2026)</a:t>
+            </a:r>
+          </a:p>
+        </p:txBody>
+      </p:sp>
+      <p:sp>
+        <p:nvSpPr>
+          <p:cNvPr id="19" name="snap_bg_3"/>
+          <p:cNvSpPr/>
+          <p:nvPr/>
+        </p:nvSpPr>
+        <p:spPr>
+          <a:xfrm>
+            <a:off x="8275320" y="4526280"/>
+            <a:ext cx="3520440" cy="960120"/>
+          </a:xfrm>
+          <a:prstGeom prst="roundRect">
+            <a:avLst/>
+          </a:prstGeom>
+          <a:solidFill>
+            <a:srgbClr val="FFFFFF"/>
+          </a:solidFill>
+          <a:ln>
+            <a:solidFill>
+              <a:srgbClr val="D8D2C6"/>
+            </a:solidFill>
+          </a:ln>
+        </p:spPr>
+        <p:style>
+          <a:lnRef idx="1">
+            <a:schemeClr val="accent1"/>
+          </a:lnRef>
+          <a:fillRef idx="3">
+            <a:schemeClr val="accent1"/>
+          </a:fillRef>
+          <a:effectRef idx="2">
+            <a:schemeClr val="accent1"/>
+          </a:effectRef>
+          <a:fontRef idx="minor">
+            <a:schemeClr val="lt1"/>
+          </a:fontRef>
+        </p:style>
+        <p:txBody>
+          <a:bodyPr rtlCol="0" anchor="ctr"/>
+          <a:lstStyle/>
+          <a:p>
+            <a:pPr algn="ctr"/>
+          </a:p>
+        </p:txBody>
+      </p:sp>
+      <p:sp>
+        <p:nvSpPr>
+          <p:cNvPr id="20" name="snap_3"/>
+          <p:cNvSpPr txBox="1"/>
+          <p:nvPr/>
+        </p:nvSpPr>
+        <p:spPr>
+          <a:xfrm>
+            <a:off x="8403336" y="4590288"/>
+            <a:ext cx="3246120" cy="822960"/>
+          </a:xfrm>
+          <a:prstGeom prst="rect">
+            <a:avLst/>
+          </a:prstGeom>
+          <a:noFill/>
+        </p:spPr>
+        <p:txBody>
+          <a:bodyPr wrap="square" anchor="t">
+            <a:spAutoFit/>
+          </a:bodyPr>
+          <a:lstStyle/>
+          <a:p>
+            <a:pPr>
+              <a:spcAft>
+                <a:spcPts val="300"/>
+              </a:spcAft>
+            </a:pPr>
+            <a:r>
+              <a:rPr sz="1000" b="1">
+                <a:solidFill>
+                  <a:srgbClr val="5B6B7C"/>
+                </a:solidFill>
+                <a:latin typeface="Calibri"/>
+              </a:rPr>
+              <a:t>COMPLIANCE</a:t>
+            </a:r>
+          </a:p>
+          <a:p>
+            <a:pPr>
+              <a:spcAft>
+                <a:spcPts val="300"/>
+              </a:spcAft>
+            </a:pPr>
+            <a:r>
+              <a:rPr sz="1300" b="1">
+                <a:solidFill>
+                  <a:srgbClr val="0E2744"/>
+                </a:solidFill>
+                <a:latin typeface="Calibri"/>
+              </a:rPr>
+              <a:t>Green | PV-only lexicon | ET/MF reactive-only</a:t>
+            </a:r>
+          </a:p>
+        </p:txBody>
+      </p:sp>
+      <p:sp>
+        <p:nvSpPr>
+          <p:cNvPr id="21" name="meta"/>
+          <p:cNvSpPr txBox="1"/>
+          <p:nvPr/>
+        </p:nvSpPr>
+        <p:spPr>
+          <a:xfrm>
+            <a:off x="411480" y="5623560"/>
+            <a:ext cx="11365992" cy="731520"/>
+          </a:xfrm>
+          <a:prstGeom prst="rect">
+            <a:avLst/>
+          </a:prstGeom>
+          <a:noFill/>
+        </p:spPr>
+        <p:txBody>
+          <a:bodyPr wrap="square" anchor="t">
+            <a:spAutoFit/>
+          </a:bodyPr>
+          <a:lstStyle/>
+          <a:p>
+            <a:pPr>
+              <a:spcAft>
+                <a:spcPts val="300"/>
+              </a:spcAft>
+            </a:pPr>
+            <a:r>
+              <a:rPr sz="1100" b="1">
+                <a:solidFill>
+                  <a:srgbClr val="5B6B7C"/>
+                </a:solidFill>
+                <a:latin typeface="Calibri"/>
+              </a:rPr>
+              <a:t>DECISION NEEDED BY:  [YYYY-MM-DD]</a:t>
+            </a:r>
+          </a:p>
+          <a:p>
+            <a:pPr>
+              <a:spcAft>
+                <a:spcPts val="300"/>
+              </a:spcAft>
+            </a:pPr>
+            <a:r>
+              <a:rPr sz="1100" b="1">
+                <a:solidFill>
+                  <a:srgbClr val="5B6B7C"/>
+                </a:solidFill>
+                <a:latin typeface="Calibri"/>
+              </a:rPr>
+              <a:t>OWNER:  PM, with GM for HQ send</a:t>
+            </a:r>
+          </a:p>
+          <a:p>
+            <a:pPr>
+              <a:spcAft>
+                <a:spcPts val="300"/>
+              </a:spcAft>
+            </a:pPr>
+            <a:r>
+              <a:rPr sz="1100" b="1">
+                <a:solidFill>
+                  <a:srgbClr val="5B6B7C"/>
+                </a:solidFill>
+                <a:latin typeface="Calibri"/>
+              </a:rPr>
+              <a:t>GOES INTO:  Standing biweekly HQ update</a:t>
+            </a:r>
+          </a:p>
+        </p:txBody>
+      </p:sp>
+      <p:sp>
+        <p:nvSpPr>
+          <p:cNvPr id="22" name="footer_rule"/>
+          <p:cNvSpPr/>
+          <p:nvPr/>
+        </p:nvSpPr>
+        <p:spPr>
+          <a:xfrm>
+            <a:off x="411480" y="6446520"/>
+            <a:ext cx="11365992" cy="18288"/>
+          </a:xfrm>
+          <a:prstGeom prst="rect">
+            <a:avLst/>
+          </a:prstGeom>
+          <a:solidFill>
+            <a:srgbClr val="D8D2C6"/>
+          </a:solidFill>
+          <a:ln>
+            <a:noFill/>
+          </a:ln>
+        </p:spPr>
+        <p:style>
+          <a:lnRef idx="1">
+            <a:schemeClr val="accent1"/>
+          </a:lnRef>
+          <a:fillRef idx="3">
+            <a:schemeClr val="accent1"/>
+          </a:fillRef>
+          <a:effectRef idx="2">
+            <a:schemeClr val="accent1"/>
+          </a:effectRef>
+          <a:fontRef idx="minor">
+            <a:schemeClr val="lt1"/>
+          </a:fontRef>
+        </p:style>
+        <p:txBody>
+          <a:bodyPr rtlCol="0" anchor="ctr"/>
+          <a:lstStyle/>
+          <a:p>
+            <a:pPr algn="ctr"/>
+          </a:p>
+        </p:txBody>
+      </p:sp>
+      <p:sp>
+        <p:nvSpPr>
+          <p:cNvPr id="23" name="footer"/>
+          <p:cNvSpPr txBox="1"/>
+          <p:nvPr/>
+        </p:nvSpPr>
+        <p:spPr>
+          <a:xfrm>
+            <a:off x="411480" y="6473952"/>
+            <a:ext cx="11365992" cy="256032"/>
+          </a:xfrm>
+          <a:prstGeom prst="rect">
+            <a:avLst/>
+          </a:prstGeom>
+          <a:noFill/>
+        </p:spPr>
+        <p:txBody>
+          <a:bodyPr wrap="square" anchor="t">
+            <a:spAutoFit/>
+          </a:bodyPr>
+          <a:lstStyle/>
+          <a:p>
+            <a:pPr>
+              <a:spcAft>
+                <a:spcPts val="300"/>
+              </a:spcAft>
+            </a:pPr>
+            <a:r>
+              <a:rPr sz="1000" b="0">
+                <a:solidFill>
+                  <a:srgbClr val="5B6B7C"/>
+                </a:solidFill>
+                <a:latin typeface="Calibri"/>
+              </a:rPr>
+              <a:t>Patterns only - no named HCPs, patient stories, unpublished dossier data  |  1 / 5</a:t>
+            </a:r>
+          </a:p>
+        </p:txBody>
+      </p:sp>
     </p:spTree>
   </p:cSld>
   <p:clrMapOvr>
@@ -3134,30 +4126,998 @@
         <p:nvPr/>
       </p:nvGrpSpPr>
       <p:grpSpPr/>
-      <p:pic>
-        <p:nvPicPr>
-          <p:cNvPr id="2" name="Picture 1" descr="example-2.png"/>
-          <p:cNvPicPr>
-            <a:picLocks noChangeAspect="1"/>
-          </p:cNvPicPr>
-          <p:nvPr/>
-        </p:nvPicPr>
-        <p:blipFill>
-          <a:blip r:embed="rId2"/>
-          <a:stretch>
-            <a:fillRect/>
-          </a:stretch>
-        </p:blipFill>
+      <p:sp>
+        <p:nvSpPr>
+          <p:cNvPr id="2" name="bg"/>
+          <p:cNvSpPr/>
+          <p:nvPr/>
+        </p:nvSpPr>
         <p:spPr>
           <a:xfrm>
             <a:off x="0" y="0"/>
-            <a:ext cx="12191999" cy="6858000"/>
+            <a:ext cx="12191695" cy="6858000"/>
           </a:xfrm>
           <a:prstGeom prst="rect">
             <a:avLst/>
           </a:prstGeom>
-        </p:spPr>
-      </p:pic>
+          <a:solidFill>
+            <a:srgbClr val="F4F1EA"/>
+          </a:solidFill>
+          <a:ln>
+            <a:noFill/>
+          </a:ln>
+        </p:spPr>
+        <p:style>
+          <a:lnRef idx="1">
+            <a:schemeClr val="accent1"/>
+          </a:lnRef>
+          <a:fillRef idx="3">
+            <a:schemeClr val="accent1"/>
+          </a:fillRef>
+          <a:effectRef idx="2">
+            <a:schemeClr val="accent1"/>
+          </a:effectRef>
+          <a:fontRef idx="minor">
+            <a:schemeClr val="lt1"/>
+          </a:fontRef>
+        </p:style>
+        <p:txBody>
+          <a:bodyPr rtlCol="0" anchor="ctr"/>
+          <a:lstStyle/>
+          <a:p>
+            <a:pPr algn="ctr"/>
+          </a:p>
+        </p:txBody>
+      </p:sp>
+      <p:sp>
+        <p:nvSpPr>
+          <p:cNvPr id="3" name="hdr_left"/>
+          <p:cNvSpPr txBox="1"/>
+          <p:nvPr/>
+        </p:nvSpPr>
+        <p:spPr>
+          <a:xfrm>
+            <a:off x="411480" y="128016"/>
+            <a:ext cx="6400800" cy="274320"/>
+          </a:xfrm>
+          <a:prstGeom prst="rect">
+            <a:avLst/>
+          </a:prstGeom>
+          <a:noFill/>
+        </p:spPr>
+        <p:txBody>
+          <a:bodyPr wrap="square" anchor="t">
+            <a:spAutoFit/>
+          </a:bodyPr>
+          <a:lstStyle/>
+          <a:p>
+            <a:pPr>
+              <a:spcAft>
+                <a:spcPts val="300"/>
+              </a:spcAft>
+            </a:pPr>
+            <a:r>
+              <a:rPr sz="1100" b="1">
+                <a:solidFill>
+                  <a:srgbClr val="0E2744"/>
+                </a:solidFill>
+                <a:latin typeface="Calibri"/>
+              </a:rPr>
+              <a:t>BESREMi | HK PV | PM field pack</a:t>
+            </a:r>
+          </a:p>
+        </p:txBody>
+      </p:sp>
+      <p:sp>
+        <p:nvSpPr>
+          <p:cNvPr id="4" name="hdr_right"/>
+          <p:cNvSpPr txBox="1"/>
+          <p:nvPr/>
+        </p:nvSpPr>
+        <p:spPr>
+          <a:xfrm>
+            <a:off x="6583680" y="128016"/>
+            <a:ext cx="5212080" cy="274320"/>
+          </a:xfrm>
+          <a:prstGeom prst="rect">
+            <a:avLst/>
+          </a:prstGeom>
+          <a:noFill/>
+        </p:spPr>
+        <p:txBody>
+          <a:bodyPr wrap="square" anchor="t">
+            <a:spAutoFit/>
+          </a:bodyPr>
+          <a:lstStyle/>
+          <a:p>
+            <a:pPr algn="r">
+              <a:spcAft>
+                <a:spcPts val="300"/>
+              </a:spcAft>
+            </a:pPr>
+            <a:r>
+              <a:rPr sz="1100" b="1">
+                <a:solidFill>
+                  <a:srgbClr val="5B6B7C"/>
+                </a:solidFill>
+                <a:latin typeface="Calibri"/>
+              </a:rPr>
+              <a:t>Biweekly | [dates] | Mid | Internal | De-identified</a:t>
+            </a:r>
+          </a:p>
+        </p:txBody>
+      </p:sp>
+      <p:sp>
+        <p:nvSpPr>
+          <p:cNvPr id="5" name="kicker"/>
+          <p:cNvSpPr txBox="1"/>
+          <p:nvPr/>
+        </p:nvSpPr>
+        <p:spPr>
+          <a:xfrm>
+            <a:off x="411480" y="420624"/>
+            <a:ext cx="11338560" cy="237744"/>
+          </a:xfrm>
+          <a:prstGeom prst="rect">
+            <a:avLst/>
+          </a:prstGeom>
+          <a:noFill/>
+        </p:spPr>
+        <p:txBody>
+          <a:bodyPr wrap="square" anchor="t">
+            <a:spAutoFit/>
+          </a:bodyPr>
+          <a:lstStyle/>
+          <a:p>
+            <a:pPr>
+              <a:spcAft>
+                <a:spcPts val="300"/>
+              </a:spcAft>
+            </a:pPr>
+            <a:r>
+              <a:rPr sz="1100" b="1">
+                <a:solidFill>
+                  <a:srgbClr val="1B7A6E"/>
+                </a:solidFill>
+                <a:latin typeface="Calibri"/>
+              </a:rPr>
+              <a:t>FIVE-SECOND SCORECARD</a:t>
+            </a:r>
+          </a:p>
+        </p:txBody>
+      </p:sp>
+      <p:sp>
+        <p:nvSpPr>
+          <p:cNvPr id="6" name="title"/>
+          <p:cNvSpPr txBox="1"/>
+          <p:nvPr/>
+        </p:nvSpPr>
+        <p:spPr>
+          <a:xfrm>
+            <a:off x="411480" y="658368"/>
+            <a:ext cx="11338560" cy="594360"/>
+          </a:xfrm>
+          <a:prstGeom prst="rect">
+            <a:avLst/>
+          </a:prstGeom>
+          <a:noFill/>
+        </p:spPr>
+        <p:txBody>
+          <a:bodyPr wrap="square" anchor="t">
+            <a:spAutoFit/>
+          </a:bodyPr>
+          <a:lstStyle/>
+          <a:p>
+            <a:pPr>
+              <a:spcAft>
+                <a:spcPts val="300"/>
+              </a:spcAft>
+            </a:pPr>
+            <a:r>
+              <a:rPr sz="2600" b="1">
+                <a:solidFill>
+                  <a:srgbClr val="0E2744"/>
+                </a:solidFill>
+                <a:latin typeface="Calibri"/>
+              </a:rPr>
+              <a:t>Initiation, not awareness, is the stall.</a:t>
+            </a:r>
+          </a:p>
+        </p:txBody>
+      </p:sp>
+      <p:sp>
+        <p:nvSpPr>
+          <p:cNvPr id="7" name="rag_bg_1"/>
+          <p:cNvSpPr/>
+          <p:nvPr/>
+        </p:nvSpPr>
+        <p:spPr>
+          <a:xfrm>
+            <a:off x="411480" y="1353312"/>
+            <a:ext cx="3520440" cy="4892040"/>
+          </a:xfrm>
+          <a:prstGeom prst="roundRect">
+            <a:avLst/>
+          </a:prstGeom>
+          <a:solidFill>
+            <a:srgbClr val="FFFFFF"/>
+          </a:solidFill>
+          <a:ln>
+            <a:solidFill>
+              <a:srgbClr val="D8D2C6"/>
+            </a:solidFill>
+          </a:ln>
+        </p:spPr>
+        <p:style>
+          <a:lnRef idx="1">
+            <a:schemeClr val="accent1"/>
+          </a:lnRef>
+          <a:fillRef idx="3">
+            <a:schemeClr val="accent1"/>
+          </a:fillRef>
+          <a:effectRef idx="2">
+            <a:schemeClr val="accent1"/>
+          </a:effectRef>
+          <a:fontRef idx="minor">
+            <a:schemeClr val="lt1"/>
+          </a:fontRef>
+        </p:style>
+        <p:txBody>
+          <a:bodyPr rtlCol="0" anchor="ctr"/>
+          <a:lstStyle/>
+          <a:p>
+            <a:pPr algn="ctr"/>
+          </a:p>
+        </p:txBody>
+      </p:sp>
+      <p:sp>
+        <p:nvSpPr>
+          <p:cNvPr id="8" name="rag_pill_1"/>
+          <p:cNvSpPr/>
+          <p:nvPr/>
+        </p:nvSpPr>
+        <p:spPr>
+          <a:xfrm>
+            <a:off x="2560320" y="1444752"/>
+            <a:ext cx="1097280" cy="274320"/>
+          </a:xfrm>
+          <a:prstGeom prst="roundRect">
+            <a:avLst/>
+          </a:prstGeom>
+          <a:solidFill>
+            <a:srgbClr val="F8EDD6"/>
+          </a:solidFill>
+          <a:ln>
+            <a:noFill/>
+          </a:ln>
+        </p:spPr>
+        <p:style>
+          <a:lnRef idx="1">
+            <a:schemeClr val="accent1"/>
+          </a:lnRef>
+          <a:fillRef idx="3">
+            <a:schemeClr val="accent1"/>
+          </a:fillRef>
+          <a:effectRef idx="2">
+            <a:schemeClr val="accent1"/>
+          </a:effectRef>
+          <a:fontRef idx="minor">
+            <a:schemeClr val="lt1"/>
+          </a:fontRef>
+        </p:style>
+        <p:txBody>
+          <a:bodyPr rtlCol="0" anchor="ctr"/>
+          <a:lstStyle/>
+          <a:p>
+            <a:pPr algn="ctr"/>
+          </a:p>
+        </p:txBody>
+      </p:sp>
+      <p:sp>
+        <p:nvSpPr>
+          <p:cNvPr id="9" name="rag_name_1"/>
+          <p:cNvSpPr txBox="1"/>
+          <p:nvPr/>
+        </p:nvSpPr>
+        <p:spPr>
+          <a:xfrm>
+            <a:off x="557784" y="1444752"/>
+            <a:ext cx="1920240" cy="256032"/>
+          </a:xfrm>
+          <a:prstGeom prst="rect">
+            <a:avLst/>
+          </a:prstGeom>
+          <a:noFill/>
+        </p:spPr>
+        <p:txBody>
+          <a:bodyPr wrap="square" anchor="t">
+            <a:spAutoFit/>
+          </a:bodyPr>
+          <a:lstStyle/>
+          <a:p>
+            <a:pPr>
+              <a:spcAft>
+                <a:spcPts val="300"/>
+              </a:spcAft>
+            </a:pPr>
+            <a:r>
+              <a:rPr sz="1100" b="1">
+                <a:solidFill>
+                  <a:srgbClr val="5B6B7C"/>
+                </a:solidFill>
+                <a:latin typeface="Calibri"/>
+              </a:rPr>
+              <a:t>UPTAKE VS PLAN</a:t>
+            </a:r>
+          </a:p>
+        </p:txBody>
+      </p:sp>
+      <p:sp>
+        <p:nvSpPr>
+          <p:cNvPr id="10" name="rag_pill_txt_1"/>
+          <p:cNvSpPr txBox="1"/>
+          <p:nvPr/>
+        </p:nvSpPr>
+        <p:spPr>
+          <a:xfrm>
+            <a:off x="2624328" y="1463040"/>
+            <a:ext cx="960120" cy="237744"/>
+          </a:xfrm>
+          <a:prstGeom prst="rect">
+            <a:avLst/>
+          </a:prstGeom>
+          <a:noFill/>
+        </p:spPr>
+        <p:txBody>
+          <a:bodyPr wrap="square" anchor="t">
+            <a:spAutoFit/>
+          </a:bodyPr>
+          <a:lstStyle/>
+          <a:p>
+            <a:pPr>
+              <a:spcAft>
+                <a:spcPts val="300"/>
+              </a:spcAft>
+            </a:pPr>
+            <a:r>
+              <a:rPr sz="1000" b="1">
+                <a:solidFill>
+                  <a:srgbClr val="B86E13"/>
+                </a:solidFill>
+                <a:latin typeface="Calibri"/>
+              </a:rPr>
+              <a:t>AMBER</a:t>
+            </a:r>
+          </a:p>
+        </p:txBody>
+      </p:sp>
+      <p:sp>
+        <p:nvSpPr>
+          <p:cNvPr id="11" name="rag_body_1"/>
+          <p:cNvSpPr txBox="1"/>
+          <p:nvPr/>
+        </p:nvSpPr>
+        <p:spPr>
+          <a:xfrm>
+            <a:off x="557784" y="1783080"/>
+            <a:ext cx="3246120" cy="4297680"/>
+          </a:xfrm>
+          <a:prstGeom prst="rect">
+            <a:avLst/>
+          </a:prstGeom>
+          <a:noFill/>
+        </p:spPr>
+        <p:txBody>
+          <a:bodyPr wrap="square" anchor="t">
+            <a:spAutoFit/>
+          </a:bodyPr>
+          <a:lstStyle/>
+          <a:p>
+            <a:pPr>
+              <a:spcAft>
+                <a:spcPts val="300"/>
+              </a:spcAft>
+            </a:pPr>
+            <a:r>
+              <a:rPr sz="1800" b="1">
+                <a:solidFill>
+                  <a:srgbClr val="0E2744"/>
+                </a:solidFill>
+                <a:latin typeface="Calibri"/>
+              </a:rPr>
+              <a:t>Awareness holds; initiation is slow.</a:t>
+            </a:r>
+          </a:p>
+          <a:p>
+            <a:pPr>
+              <a:spcAft>
+                <a:spcPts val="300"/>
+              </a:spcAft>
+            </a:pPr>
+            <a:r>
+              <a:rPr sz="1300" b="0">
+                <a:solidFill>
+                  <a:srgbClr val="5B6B7C"/>
+                </a:solidFill>
+                <a:latin typeface="Calibri"/>
+              </a:rPr>
+              <a:t>Definition: private uptake vs agreed HQ plan - not call volume.</a:t>
+            </a:r>
+          </a:p>
+          <a:p>
+            <a:pPr>
+              <a:spcAft>
+                <a:spcPts val="300"/>
+              </a:spcAft>
+            </a:pPr>
+            <a:r>
+              <a:rPr sz="1400" b="1">
+                <a:solidFill>
+                  <a:srgbClr val="1C2A3A"/>
+                </a:solidFill>
+                <a:latin typeface="Calibri"/>
+              </a:rPr>
+              <a:t>Vs last cycle: unchanged conversion quality.</a:t>
+            </a:r>
+          </a:p>
+        </p:txBody>
+      </p:sp>
+      <p:sp>
+        <p:nvSpPr>
+          <p:cNvPr id="12" name="rag_bg_2"/>
+          <p:cNvSpPr/>
+          <p:nvPr/>
+        </p:nvSpPr>
+        <p:spPr>
+          <a:xfrm>
+            <a:off x="4343400" y="1353312"/>
+            <a:ext cx="3520440" cy="4892040"/>
+          </a:xfrm>
+          <a:prstGeom prst="roundRect">
+            <a:avLst/>
+          </a:prstGeom>
+          <a:solidFill>
+            <a:srgbClr val="FFFFFF"/>
+          </a:solidFill>
+          <a:ln>
+            <a:solidFill>
+              <a:srgbClr val="D8D2C6"/>
+            </a:solidFill>
+          </a:ln>
+        </p:spPr>
+        <p:style>
+          <a:lnRef idx="1">
+            <a:schemeClr val="accent1"/>
+          </a:lnRef>
+          <a:fillRef idx="3">
+            <a:schemeClr val="accent1"/>
+          </a:fillRef>
+          <a:effectRef idx="2">
+            <a:schemeClr val="accent1"/>
+          </a:effectRef>
+          <a:fontRef idx="minor">
+            <a:schemeClr val="lt1"/>
+          </a:fontRef>
+        </p:style>
+        <p:txBody>
+          <a:bodyPr rtlCol="0" anchor="ctr"/>
+          <a:lstStyle/>
+          <a:p>
+            <a:pPr algn="ctr"/>
+          </a:p>
+        </p:txBody>
+      </p:sp>
+      <p:sp>
+        <p:nvSpPr>
+          <p:cNvPr id="13" name="rag_pill_2"/>
+          <p:cNvSpPr/>
+          <p:nvPr/>
+        </p:nvSpPr>
+        <p:spPr>
+          <a:xfrm>
+            <a:off x="6492240" y="1444752"/>
+            <a:ext cx="1097280" cy="274320"/>
+          </a:xfrm>
+          <a:prstGeom prst="roundRect">
+            <a:avLst/>
+          </a:prstGeom>
+          <a:solidFill>
+            <a:srgbClr val="F8EDD6"/>
+          </a:solidFill>
+          <a:ln>
+            <a:noFill/>
+          </a:ln>
+        </p:spPr>
+        <p:style>
+          <a:lnRef idx="1">
+            <a:schemeClr val="accent1"/>
+          </a:lnRef>
+          <a:fillRef idx="3">
+            <a:schemeClr val="accent1"/>
+          </a:fillRef>
+          <a:effectRef idx="2">
+            <a:schemeClr val="accent1"/>
+          </a:effectRef>
+          <a:fontRef idx="minor">
+            <a:schemeClr val="lt1"/>
+          </a:fontRef>
+        </p:style>
+        <p:txBody>
+          <a:bodyPr rtlCol="0" anchor="ctr"/>
+          <a:lstStyle/>
+          <a:p>
+            <a:pPr algn="ctr"/>
+          </a:p>
+        </p:txBody>
+      </p:sp>
+      <p:sp>
+        <p:nvSpPr>
+          <p:cNvPr id="14" name="rag_name_2"/>
+          <p:cNvSpPr txBox="1"/>
+          <p:nvPr/>
+        </p:nvSpPr>
+        <p:spPr>
+          <a:xfrm>
+            <a:off x="4489704" y="1444752"/>
+            <a:ext cx="1920240" cy="256032"/>
+          </a:xfrm>
+          <a:prstGeom prst="rect">
+            <a:avLst/>
+          </a:prstGeom>
+          <a:noFill/>
+        </p:spPr>
+        <p:txBody>
+          <a:bodyPr wrap="square" anchor="t">
+            <a:spAutoFit/>
+          </a:bodyPr>
+          <a:lstStyle/>
+          <a:p>
+            <a:pPr>
+              <a:spcAft>
+                <a:spcPts val="300"/>
+              </a:spcAft>
+            </a:pPr>
+            <a:r>
+              <a:rPr sz="1100" b="1">
+                <a:solidFill>
+                  <a:srgbClr val="5B6B7C"/>
+                </a:solidFill>
+                <a:latin typeface="Calibri"/>
+              </a:rPr>
+              <a:t>FORMULARY TRAJECTORY</a:t>
+            </a:r>
+          </a:p>
+        </p:txBody>
+      </p:sp>
+      <p:sp>
+        <p:nvSpPr>
+          <p:cNvPr id="15" name="rag_pill_txt_2"/>
+          <p:cNvSpPr txBox="1"/>
+          <p:nvPr/>
+        </p:nvSpPr>
+        <p:spPr>
+          <a:xfrm>
+            <a:off x="6556248" y="1463040"/>
+            <a:ext cx="960120" cy="237744"/>
+          </a:xfrm>
+          <a:prstGeom prst="rect">
+            <a:avLst/>
+          </a:prstGeom>
+          <a:noFill/>
+        </p:spPr>
+        <p:txBody>
+          <a:bodyPr wrap="square" anchor="t">
+            <a:spAutoFit/>
+          </a:bodyPr>
+          <a:lstStyle/>
+          <a:p>
+            <a:pPr>
+              <a:spcAft>
+                <a:spcPts val="300"/>
+              </a:spcAft>
+            </a:pPr>
+            <a:r>
+              <a:rPr sz="1000" b="1">
+                <a:solidFill>
+                  <a:srgbClr val="B86E13"/>
+                </a:solidFill>
+                <a:latin typeface="Calibri"/>
+              </a:rPr>
+              <a:t>AMBER</a:t>
+            </a:r>
+          </a:p>
+        </p:txBody>
+      </p:sp>
+      <p:sp>
+        <p:nvSpPr>
+          <p:cNvPr id="16" name="rag_body_2"/>
+          <p:cNvSpPr txBox="1"/>
+          <p:nvPr/>
+        </p:nvSpPr>
+        <p:spPr>
+          <a:xfrm>
+            <a:off x="4489704" y="1783080"/>
+            <a:ext cx="3246120" cy="4297680"/>
+          </a:xfrm>
+          <a:prstGeom prst="rect">
+            <a:avLst/>
+          </a:prstGeom>
+          <a:noFill/>
+        </p:spPr>
+        <p:txBody>
+          <a:bodyPr wrap="square" anchor="t">
+            <a:spAutoFit/>
+          </a:bodyPr>
+          <a:lstStyle/>
+          <a:p>
+            <a:pPr>
+              <a:spcAft>
+                <a:spcPts val="300"/>
+              </a:spcAft>
+            </a:pPr>
+            <a:r>
+              <a:rPr sz="1800" b="1">
+                <a:solidFill>
+                  <a:srgbClr val="0E2744"/>
+                </a:solidFill>
+                <a:latin typeface="Calibri"/>
+              </a:rPr>
+              <a:t>Field themes are usable; dossier not advanced this cycle.</a:t>
+            </a:r>
+          </a:p>
+          <a:p>
+            <a:pPr>
+              <a:spcAft>
+                <a:spcPts val="300"/>
+              </a:spcAft>
+            </a:pPr>
+            <a:r>
+              <a:rPr sz="1300" b="0">
+                <a:solidFill>
+                  <a:srgbClr val="5B6B7C"/>
+                </a:solidFill>
+                <a:latin typeface="Calibri"/>
+              </a:rPr>
+              <a:t>Definition: strengthened / delayed / no change to HADF packaging.</a:t>
+            </a:r>
+          </a:p>
+          <a:p>
+            <a:pPr>
+              <a:spcAft>
+                <a:spcPts val="300"/>
+              </a:spcAft>
+            </a:pPr>
+            <a:r>
+              <a:rPr sz="1400" b="1">
+                <a:solidFill>
+                  <a:srgbClr val="1C2A3A"/>
+                </a:solidFill>
+                <a:latin typeface="Calibri"/>
+              </a:rPr>
+              <a:t>Vs last cycle: no new evidence gap; no new unlock.</a:t>
+            </a:r>
+          </a:p>
+        </p:txBody>
+      </p:sp>
+      <p:sp>
+        <p:nvSpPr>
+          <p:cNvPr id="17" name="rag_bg_3"/>
+          <p:cNvSpPr/>
+          <p:nvPr/>
+        </p:nvSpPr>
+        <p:spPr>
+          <a:xfrm>
+            <a:off x="8275320" y="1353312"/>
+            <a:ext cx="3520440" cy="4892040"/>
+          </a:xfrm>
+          <a:prstGeom prst="roundRect">
+            <a:avLst/>
+          </a:prstGeom>
+          <a:solidFill>
+            <a:srgbClr val="FFFFFF"/>
+          </a:solidFill>
+          <a:ln>
+            <a:solidFill>
+              <a:srgbClr val="D8D2C6"/>
+            </a:solidFill>
+          </a:ln>
+        </p:spPr>
+        <p:style>
+          <a:lnRef idx="1">
+            <a:schemeClr val="accent1"/>
+          </a:lnRef>
+          <a:fillRef idx="3">
+            <a:schemeClr val="accent1"/>
+          </a:fillRef>
+          <a:effectRef idx="2">
+            <a:schemeClr val="accent1"/>
+          </a:effectRef>
+          <a:fontRef idx="minor">
+            <a:schemeClr val="lt1"/>
+          </a:fontRef>
+        </p:style>
+        <p:txBody>
+          <a:bodyPr rtlCol="0" anchor="ctr"/>
+          <a:lstStyle/>
+          <a:p>
+            <a:pPr algn="ctr"/>
+          </a:p>
+        </p:txBody>
+      </p:sp>
+      <p:sp>
+        <p:nvSpPr>
+          <p:cNvPr id="18" name="rag_pill_3"/>
+          <p:cNvSpPr/>
+          <p:nvPr/>
+        </p:nvSpPr>
+        <p:spPr>
+          <a:xfrm>
+            <a:off x="10424160" y="1444752"/>
+            <a:ext cx="1097280" cy="274320"/>
+          </a:xfrm>
+          <a:prstGeom prst="roundRect">
+            <a:avLst/>
+          </a:prstGeom>
+          <a:solidFill>
+            <a:srgbClr val="E3F3EA"/>
+          </a:solidFill>
+          <a:ln>
+            <a:noFill/>
+          </a:ln>
+        </p:spPr>
+        <p:style>
+          <a:lnRef idx="1">
+            <a:schemeClr val="accent1"/>
+          </a:lnRef>
+          <a:fillRef idx="3">
+            <a:schemeClr val="accent1"/>
+          </a:fillRef>
+          <a:effectRef idx="2">
+            <a:schemeClr val="accent1"/>
+          </a:effectRef>
+          <a:fontRef idx="minor">
+            <a:schemeClr val="lt1"/>
+          </a:fontRef>
+        </p:style>
+        <p:txBody>
+          <a:bodyPr rtlCol="0" anchor="ctr"/>
+          <a:lstStyle/>
+          <a:p>
+            <a:pPr algn="ctr"/>
+          </a:p>
+        </p:txBody>
+      </p:sp>
+      <p:sp>
+        <p:nvSpPr>
+          <p:cNvPr id="19" name="rag_name_3"/>
+          <p:cNvSpPr txBox="1"/>
+          <p:nvPr/>
+        </p:nvSpPr>
+        <p:spPr>
+          <a:xfrm>
+            <a:off x="8421624" y="1444752"/>
+            <a:ext cx="1920240" cy="256032"/>
+          </a:xfrm>
+          <a:prstGeom prst="rect">
+            <a:avLst/>
+          </a:prstGeom>
+          <a:noFill/>
+        </p:spPr>
+        <p:txBody>
+          <a:bodyPr wrap="square" anchor="t">
+            <a:spAutoFit/>
+          </a:bodyPr>
+          <a:lstStyle/>
+          <a:p>
+            <a:pPr>
+              <a:spcAft>
+                <a:spcPts val="300"/>
+              </a:spcAft>
+            </a:pPr>
+            <a:r>
+              <a:rPr sz="1100" b="1">
+                <a:solidFill>
+                  <a:srgbClr val="5B6B7C"/>
+                </a:solidFill>
+                <a:latin typeface="Calibri"/>
+              </a:rPr>
+              <a:t>COMPLIANCE</a:t>
+            </a:r>
+          </a:p>
+        </p:txBody>
+      </p:sp>
+      <p:sp>
+        <p:nvSpPr>
+          <p:cNvPr id="20" name="rag_pill_txt_3"/>
+          <p:cNvSpPr txBox="1"/>
+          <p:nvPr/>
+        </p:nvSpPr>
+        <p:spPr>
+          <a:xfrm>
+            <a:off x="10488168" y="1463040"/>
+            <a:ext cx="960120" cy="237744"/>
+          </a:xfrm>
+          <a:prstGeom prst="rect">
+            <a:avLst/>
+          </a:prstGeom>
+          <a:noFill/>
+        </p:spPr>
+        <p:txBody>
+          <a:bodyPr wrap="square" anchor="t">
+            <a:spAutoFit/>
+          </a:bodyPr>
+          <a:lstStyle/>
+          <a:p>
+            <a:pPr>
+              <a:spcAft>
+                <a:spcPts val="300"/>
+              </a:spcAft>
+            </a:pPr>
+            <a:r>
+              <a:rPr sz="1000" b="1">
+                <a:solidFill>
+                  <a:srgbClr val="1F7A4D"/>
+                </a:solidFill>
+                <a:latin typeface="Calibri"/>
+              </a:rPr>
+              <a:t>GREEN</a:t>
+            </a:r>
+          </a:p>
+        </p:txBody>
+      </p:sp>
+      <p:sp>
+        <p:nvSpPr>
+          <p:cNvPr id="21" name="rag_body_3"/>
+          <p:cNvSpPr txBox="1"/>
+          <p:nvPr/>
+        </p:nvSpPr>
+        <p:spPr>
+          <a:xfrm>
+            <a:off x="8421624" y="1783080"/>
+            <a:ext cx="3246120" cy="4297680"/>
+          </a:xfrm>
+          <a:prstGeom prst="rect">
+            <a:avLst/>
+          </a:prstGeom>
+          <a:noFill/>
+        </p:spPr>
+        <p:txBody>
+          <a:bodyPr wrap="square" anchor="t">
+            <a:spAutoFit/>
+          </a:bodyPr>
+          <a:lstStyle/>
+          <a:p>
+            <a:pPr>
+              <a:spcAft>
+                <a:spcPts val="300"/>
+              </a:spcAft>
+            </a:pPr>
+            <a:r>
+              <a:rPr sz="1800" b="1">
+                <a:solidFill>
+                  <a:srgbClr val="0E2744"/>
+                </a:solidFill>
+                <a:latin typeface="Calibri"/>
+              </a:rPr>
+              <a:t>No uncleared claims. ET/MF stayed reactive-only.</a:t>
+            </a:r>
+          </a:p>
+          <a:p>
+            <a:pPr>
+              <a:spcAft>
+                <a:spcPts val="300"/>
+              </a:spcAft>
+            </a:pPr>
+            <a:r>
+              <a:rPr sz="1300" b="0">
+                <a:solidFill>
+                  <a:srgbClr val="5B6B7C"/>
+                </a:solidFill>
+                <a:latin typeface="Calibri"/>
+              </a:rPr>
+              <a:t>Definition: materials cleared; no open UMAO/HKAPI issues.</a:t>
+            </a:r>
+          </a:p>
+          <a:p>
+            <a:pPr>
+              <a:spcAft>
+                <a:spcPts val="300"/>
+              </a:spcAft>
+            </a:pPr>
+            <a:r>
+              <a:rPr sz="1400" b="1">
+                <a:solidFill>
+                  <a:srgbClr val="1C2A3A"/>
+                </a:solidFill>
+                <a:latin typeface="Calibri"/>
+              </a:rPr>
+              <a:t>Vs last cycle: clean. Keep raw notes in the vault.</a:t>
+            </a:r>
+          </a:p>
+        </p:txBody>
+      </p:sp>
+      <p:sp>
+        <p:nvSpPr>
+          <p:cNvPr id="22" name="footer_rule"/>
+          <p:cNvSpPr/>
+          <p:nvPr/>
+        </p:nvSpPr>
+        <p:spPr>
+          <a:xfrm>
+            <a:off x="411480" y="6446520"/>
+            <a:ext cx="11365992" cy="18288"/>
+          </a:xfrm>
+          <a:prstGeom prst="rect">
+            <a:avLst/>
+          </a:prstGeom>
+          <a:solidFill>
+            <a:srgbClr val="D8D2C6"/>
+          </a:solidFill>
+          <a:ln>
+            <a:noFill/>
+          </a:ln>
+        </p:spPr>
+        <p:style>
+          <a:lnRef idx="1">
+            <a:schemeClr val="accent1"/>
+          </a:lnRef>
+          <a:fillRef idx="3">
+            <a:schemeClr val="accent1"/>
+          </a:fillRef>
+          <a:effectRef idx="2">
+            <a:schemeClr val="accent1"/>
+          </a:effectRef>
+          <a:fontRef idx="minor">
+            <a:schemeClr val="lt1"/>
+          </a:fontRef>
+        </p:style>
+        <p:txBody>
+          <a:bodyPr rtlCol="0" anchor="ctr"/>
+          <a:lstStyle/>
+          <a:p>
+            <a:pPr algn="ctr"/>
+          </a:p>
+        </p:txBody>
+      </p:sp>
+      <p:sp>
+        <p:nvSpPr>
+          <p:cNvPr id="23" name="footer"/>
+          <p:cNvSpPr txBox="1"/>
+          <p:nvPr/>
+        </p:nvSpPr>
+        <p:spPr>
+          <a:xfrm>
+            <a:off x="411480" y="6473952"/>
+            <a:ext cx="11365992" cy="256032"/>
+          </a:xfrm>
+          <a:prstGeom prst="rect">
+            <a:avLst/>
+          </a:prstGeom>
+          <a:noFill/>
+        </p:spPr>
+        <p:txBody>
+          <a:bodyPr wrap="square" anchor="t">
+            <a:spAutoFit/>
+          </a:bodyPr>
+          <a:lstStyle/>
+          <a:p>
+            <a:pPr>
+              <a:spcAft>
+                <a:spcPts val="300"/>
+              </a:spcAft>
+            </a:pPr>
+            <a:r>
+              <a:rPr sz="1000" b="0">
+                <a:solidFill>
+                  <a:srgbClr val="5B6B7C"/>
+                </a:solidFill>
+                <a:latin typeface="Calibri"/>
+              </a:rPr>
+              <a:t>Patterns only - no named HCPs, patient stories, unpublished dossier data  |  2 / 5</a:t>
+            </a:r>
+          </a:p>
+        </p:txBody>
+      </p:sp>
     </p:spTree>
   </p:cSld>
   <p:clrMapOvr>
@@ -3176,30 +5136,683 @@
         <p:nvPr/>
       </p:nvGrpSpPr>
       <p:grpSpPr/>
-      <p:pic>
-        <p:nvPicPr>
-          <p:cNvPr id="2" name="Picture 1" descr="example-3.png"/>
-          <p:cNvPicPr>
-            <a:picLocks noChangeAspect="1"/>
-          </p:cNvPicPr>
-          <p:nvPr/>
-        </p:nvPicPr>
-        <p:blipFill>
-          <a:blip r:embed="rId2"/>
-          <a:stretch>
-            <a:fillRect/>
-          </a:stretch>
-        </p:blipFill>
+      <p:sp>
+        <p:nvSpPr>
+          <p:cNvPr id="2" name="bg"/>
+          <p:cNvSpPr/>
+          <p:nvPr/>
+        </p:nvSpPr>
         <p:spPr>
           <a:xfrm>
             <a:off x="0" y="0"/>
-            <a:ext cx="12191999" cy="6858000"/>
+            <a:ext cx="12191695" cy="6858000"/>
           </a:xfrm>
           <a:prstGeom prst="rect">
             <a:avLst/>
           </a:prstGeom>
-        </p:spPr>
-      </p:pic>
+          <a:solidFill>
+            <a:srgbClr val="F4F1EA"/>
+          </a:solidFill>
+          <a:ln>
+            <a:noFill/>
+          </a:ln>
+        </p:spPr>
+        <p:style>
+          <a:lnRef idx="1">
+            <a:schemeClr val="accent1"/>
+          </a:lnRef>
+          <a:fillRef idx="3">
+            <a:schemeClr val="accent1"/>
+          </a:fillRef>
+          <a:effectRef idx="2">
+            <a:schemeClr val="accent1"/>
+          </a:effectRef>
+          <a:fontRef idx="minor">
+            <a:schemeClr val="lt1"/>
+          </a:fontRef>
+        </p:style>
+        <p:txBody>
+          <a:bodyPr rtlCol="0" anchor="ctr"/>
+          <a:lstStyle/>
+          <a:p>
+            <a:pPr algn="ctr"/>
+          </a:p>
+        </p:txBody>
+      </p:sp>
+      <p:sp>
+        <p:nvSpPr>
+          <p:cNvPr id="3" name="hdr_left"/>
+          <p:cNvSpPr txBox="1"/>
+          <p:nvPr/>
+        </p:nvSpPr>
+        <p:spPr>
+          <a:xfrm>
+            <a:off x="411480" y="128016"/>
+            <a:ext cx="6400800" cy="274320"/>
+          </a:xfrm>
+          <a:prstGeom prst="rect">
+            <a:avLst/>
+          </a:prstGeom>
+          <a:noFill/>
+        </p:spPr>
+        <p:txBody>
+          <a:bodyPr wrap="square" anchor="t">
+            <a:spAutoFit/>
+          </a:bodyPr>
+          <a:lstStyle/>
+          <a:p>
+            <a:pPr>
+              <a:spcAft>
+                <a:spcPts val="300"/>
+              </a:spcAft>
+            </a:pPr>
+            <a:r>
+              <a:rPr sz="1100" b="1">
+                <a:solidFill>
+                  <a:srgbClr val="0E2744"/>
+                </a:solidFill>
+                <a:latin typeface="Calibri"/>
+              </a:rPr>
+              <a:t>BESREMi | HK PV | PM field pack</a:t>
+            </a:r>
+          </a:p>
+        </p:txBody>
+      </p:sp>
+      <p:sp>
+        <p:nvSpPr>
+          <p:cNvPr id="4" name="hdr_right"/>
+          <p:cNvSpPr txBox="1"/>
+          <p:nvPr/>
+        </p:nvSpPr>
+        <p:spPr>
+          <a:xfrm>
+            <a:off x="6583680" y="128016"/>
+            <a:ext cx="5212080" cy="274320"/>
+          </a:xfrm>
+          <a:prstGeom prst="rect">
+            <a:avLst/>
+          </a:prstGeom>
+          <a:noFill/>
+        </p:spPr>
+        <p:txBody>
+          <a:bodyPr wrap="square" anchor="t">
+            <a:spAutoFit/>
+          </a:bodyPr>
+          <a:lstStyle/>
+          <a:p>
+            <a:pPr algn="r">
+              <a:spcAft>
+                <a:spcPts val="300"/>
+              </a:spcAft>
+            </a:pPr>
+            <a:r>
+              <a:rPr sz="1100" b="1">
+                <a:solidFill>
+                  <a:srgbClr val="5B6B7C"/>
+                </a:solidFill>
+                <a:latin typeface="Calibri"/>
+              </a:rPr>
+              <a:t>Biweekly | [dates] | Mid | Internal | De-identified</a:t>
+            </a:r>
+          </a:p>
+        </p:txBody>
+      </p:sp>
+      <p:sp>
+        <p:nvSpPr>
+          <p:cNvPr id="5" name="kicker"/>
+          <p:cNvSpPr txBox="1"/>
+          <p:nvPr/>
+        </p:nvSpPr>
+        <p:spPr>
+          <a:xfrm>
+            <a:off x="411480" y="420624"/>
+            <a:ext cx="11338560" cy="237744"/>
+          </a:xfrm>
+          <a:prstGeom prst="rect">
+            <a:avLst/>
+          </a:prstGeom>
+          <a:noFill/>
+        </p:spPr>
+        <p:txBody>
+          <a:bodyPr wrap="square" anchor="t">
+            <a:spAutoFit/>
+          </a:bodyPr>
+          <a:lstStyle/>
+          <a:p>
+            <a:pPr>
+              <a:spcAft>
+                <a:spcPts val="300"/>
+              </a:spcAft>
+            </a:pPr>
+            <a:r>
+              <a:rPr sz="1100" b="1">
+                <a:solidFill>
+                  <a:srgbClr val="1B7A6E"/>
+                </a:solidFill>
+                <a:latin typeface="Calibri"/>
+              </a:rPr>
+              <a:t>FIELD SIGNALS - MAX THREE</a:t>
+            </a:r>
+          </a:p>
+        </p:txBody>
+      </p:sp>
+      <p:sp>
+        <p:nvSpPr>
+          <p:cNvPr id="6" name="title"/>
+          <p:cNvSpPr txBox="1"/>
+          <p:nvPr/>
+        </p:nvSpPr>
+        <p:spPr>
+          <a:xfrm>
+            <a:off x="411480" y="658368"/>
+            <a:ext cx="11338560" cy="594360"/>
+          </a:xfrm>
+          <a:prstGeom prst="rect">
+            <a:avLst/>
+          </a:prstGeom>
+          <a:noFill/>
+        </p:spPr>
+        <p:txBody>
+          <a:bodyPr wrap="square" anchor="t">
+            <a:spAutoFit/>
+          </a:bodyPr>
+          <a:lstStyle/>
+          <a:p>
+            <a:pPr>
+              <a:spcAft>
+                <a:spcPts val="300"/>
+              </a:spcAft>
+            </a:pPr>
+            <a:r>
+              <a:rPr sz="2600" b="1">
+                <a:solidFill>
+                  <a:srgbClr val="0E2744"/>
+                </a:solidFill>
+                <a:latin typeface="Calibri"/>
+              </a:rPr>
+              <a:t>What repeated in the field - not who we visited</a:t>
+            </a:r>
+          </a:p>
+        </p:txBody>
+      </p:sp>
+      <p:sp>
+        <p:nvSpPr>
+          <p:cNvPr id="7" name="sig_bg_1"/>
+          <p:cNvSpPr/>
+          <p:nvPr/>
+        </p:nvSpPr>
+        <p:spPr>
+          <a:xfrm>
+            <a:off x="411480" y="1353312"/>
+            <a:ext cx="3520440" cy="4892040"/>
+          </a:xfrm>
+          <a:prstGeom prst="roundRect">
+            <a:avLst/>
+          </a:prstGeom>
+          <a:solidFill>
+            <a:srgbClr val="FFFFFF"/>
+          </a:solidFill>
+          <a:ln>
+            <a:solidFill>
+              <a:srgbClr val="D8D2C6"/>
+            </a:solidFill>
+          </a:ln>
+        </p:spPr>
+        <p:style>
+          <a:lnRef idx="1">
+            <a:schemeClr val="accent1"/>
+          </a:lnRef>
+          <a:fillRef idx="3">
+            <a:schemeClr val="accent1"/>
+          </a:fillRef>
+          <a:effectRef idx="2">
+            <a:schemeClr val="accent1"/>
+          </a:effectRef>
+          <a:fontRef idx="minor">
+            <a:schemeClr val="lt1"/>
+          </a:fontRef>
+        </p:style>
+        <p:txBody>
+          <a:bodyPr rtlCol="0" anchor="ctr"/>
+          <a:lstStyle/>
+          <a:p>
+            <a:pPr algn="ctr"/>
+          </a:p>
+        </p:txBody>
+      </p:sp>
+      <p:sp>
+        <p:nvSpPr>
+          <p:cNvPr id="8" name="signal_1"/>
+          <p:cNvSpPr txBox="1"/>
+          <p:nvPr/>
+        </p:nvSpPr>
+        <p:spPr>
+          <a:xfrm>
+            <a:off x="539496" y="1444752"/>
+            <a:ext cx="3246120" cy="4663440"/>
+          </a:xfrm>
+          <a:prstGeom prst="rect">
+            <a:avLst/>
+          </a:prstGeom>
+          <a:noFill/>
+        </p:spPr>
+        <p:txBody>
+          <a:bodyPr wrap="square" anchor="t">
+            <a:spAutoFit/>
+          </a:bodyPr>
+          <a:lstStyle/>
+          <a:p>
+            <a:pPr>
+              <a:spcAft>
+                <a:spcPts val="300"/>
+              </a:spcAft>
+            </a:pPr>
+            <a:r>
+              <a:rPr sz="1600" b="1">
+                <a:solidFill>
+                  <a:srgbClr val="0E2744"/>
+                </a:solidFill>
+                <a:latin typeface="Calibri"/>
+              </a:rPr>
+              <a:t>Affordability is understood; initiation is not.</a:t>
+            </a:r>
+          </a:p>
+          <a:p>
+            <a:pPr>
+              <a:spcAft>
+                <a:spcPts val="300"/>
+              </a:spcAft>
+            </a:pPr>
+            <a:r>
+              <a:rPr sz="1300" b="0">
+                <a:solidFill>
+                  <a:srgbClr val="1C2A3A"/>
+                </a:solidFill>
+                <a:latin typeface="Calibri"/>
+              </a:rPr>
+              <a:t>Observed: Priority accounts repeat PSP logic, then still do not start.</a:t>
+            </a:r>
+          </a:p>
+          <a:p>
+            <a:pPr>
+              <a:spcAft>
+                <a:spcPts val="300"/>
+              </a:spcAft>
+            </a:pPr>
+            <a:r>
+              <a:rPr sz="1300" b="0">
+                <a:solidFill>
+                  <a:srgbClr val="1C2A3A"/>
+                </a:solidFill>
+                <a:latin typeface="Calibri"/>
+              </a:rPr>
+              <a:t>So what: Uptake risk sits after affordability, not before it.</a:t>
+            </a:r>
+          </a:p>
+          <a:p>
+            <a:pPr>
+              <a:spcAft>
+                <a:spcPts val="300"/>
+              </a:spcAft>
+            </a:pPr>
+            <a:r>
+              <a:rPr sz="1300" b="1">
+                <a:solidFill>
+                  <a:srgbClr val="1B7A6E"/>
+                </a:solidFill>
+                <a:latin typeface="Calibri"/>
+              </a:rPr>
+              <a:t>Implication: Next cycle = onboarding friction, not more awareness meetings.</a:t>
+            </a:r>
+          </a:p>
+        </p:txBody>
+      </p:sp>
+      <p:sp>
+        <p:nvSpPr>
+          <p:cNvPr id="9" name="sig_bg_2"/>
+          <p:cNvSpPr/>
+          <p:nvPr/>
+        </p:nvSpPr>
+        <p:spPr>
+          <a:xfrm>
+            <a:off x="4343400" y="1353312"/>
+            <a:ext cx="3520440" cy="4892040"/>
+          </a:xfrm>
+          <a:prstGeom prst="roundRect">
+            <a:avLst/>
+          </a:prstGeom>
+          <a:solidFill>
+            <a:srgbClr val="FFFFFF"/>
+          </a:solidFill>
+          <a:ln>
+            <a:solidFill>
+              <a:srgbClr val="D8D2C6"/>
+            </a:solidFill>
+          </a:ln>
+        </p:spPr>
+        <p:style>
+          <a:lnRef idx="1">
+            <a:schemeClr val="accent1"/>
+          </a:lnRef>
+          <a:fillRef idx="3">
+            <a:schemeClr val="accent1"/>
+          </a:fillRef>
+          <a:effectRef idx="2">
+            <a:schemeClr val="accent1"/>
+          </a:effectRef>
+          <a:fontRef idx="minor">
+            <a:schemeClr val="lt1"/>
+          </a:fontRef>
+        </p:style>
+        <p:txBody>
+          <a:bodyPr rtlCol="0" anchor="ctr"/>
+          <a:lstStyle/>
+          <a:p>
+            <a:pPr algn="ctr"/>
+          </a:p>
+        </p:txBody>
+      </p:sp>
+      <p:sp>
+        <p:nvSpPr>
+          <p:cNvPr id="10" name="signal_2"/>
+          <p:cNvSpPr txBox="1"/>
+          <p:nvPr/>
+        </p:nvSpPr>
+        <p:spPr>
+          <a:xfrm>
+            <a:off x="4471416" y="1444752"/>
+            <a:ext cx="3246120" cy="4663440"/>
+          </a:xfrm>
+          <a:prstGeom prst="rect">
+            <a:avLst/>
+          </a:prstGeom>
+          <a:noFill/>
+        </p:spPr>
+        <p:txBody>
+          <a:bodyPr wrap="square" anchor="t">
+            <a:spAutoFit/>
+          </a:bodyPr>
+          <a:lstStyle/>
+          <a:p>
+            <a:pPr>
+              <a:spcAft>
+                <a:spcPts val="300"/>
+              </a:spcAft>
+            </a:pPr>
+            <a:r>
+              <a:rPr sz="1600" b="1">
+                <a:solidFill>
+                  <a:srgbClr val="0E2744"/>
+                </a:solidFill>
+                <a:latin typeface="Calibri"/>
+              </a:rPr>
+              <a:t>Price vs traditional IFN is the #1 close-blocker.</a:t>
+            </a:r>
+          </a:p>
+          <a:p>
+            <a:pPr>
+              <a:spcAft>
+                <a:spcPts val="300"/>
+              </a:spcAft>
+            </a:pPr>
+            <a:r>
+              <a:rPr sz="1300" b="0">
+                <a:solidFill>
+                  <a:srgbClr val="1C2A3A"/>
+                </a:solidFill>
+                <a:latin typeface="Calibri"/>
+              </a:rPr>
+              <a:t>Observed: Same objection across accounts: why pay a premium vs off-label IFN.</a:t>
+            </a:r>
+          </a:p>
+          <a:p>
+            <a:pPr>
+              <a:spcAft>
+                <a:spcPts val="300"/>
+              </a:spcAft>
+            </a:pPr>
+            <a:r>
+              <a:rPr sz="1300" b="0">
+                <a:solidFill>
+                  <a:srgbClr val="1C2A3A"/>
+                </a:solidFill>
+                <a:latin typeface="Calibri"/>
+              </a:rPr>
+              <a:t>So what: Stay inside approved PV evidence and dosing convenience.</a:t>
+            </a:r>
+          </a:p>
+          <a:p>
+            <a:pPr>
+              <a:spcAft>
+                <a:spcPts val="300"/>
+              </a:spcAft>
+            </a:pPr>
+            <a:r>
+              <a:rPr sz="1300" b="1">
+                <a:solidFill>
+                  <a:srgbClr val="1B7A6E"/>
+                </a:solidFill>
+                <a:latin typeface="Calibri"/>
+              </a:rPr>
+              <a:t>Implication: No IFN-to-IFN superiority claim. Lexicon response only.</a:t>
+            </a:r>
+          </a:p>
+        </p:txBody>
+      </p:sp>
+      <p:sp>
+        <p:nvSpPr>
+          <p:cNvPr id="11" name="sig_bg_3"/>
+          <p:cNvSpPr/>
+          <p:nvPr/>
+        </p:nvSpPr>
+        <p:spPr>
+          <a:xfrm>
+            <a:off x="8275320" y="1353312"/>
+            <a:ext cx="3520440" cy="4892040"/>
+          </a:xfrm>
+          <a:prstGeom prst="roundRect">
+            <a:avLst/>
+          </a:prstGeom>
+          <a:solidFill>
+            <a:srgbClr val="FFFFFF"/>
+          </a:solidFill>
+          <a:ln>
+            <a:solidFill>
+              <a:srgbClr val="D8D2C6"/>
+            </a:solidFill>
+          </a:ln>
+        </p:spPr>
+        <p:style>
+          <a:lnRef idx="1">
+            <a:schemeClr val="accent1"/>
+          </a:lnRef>
+          <a:fillRef idx="3">
+            <a:schemeClr val="accent1"/>
+          </a:fillRef>
+          <a:effectRef idx="2">
+            <a:schemeClr val="accent1"/>
+          </a:effectRef>
+          <a:fontRef idx="minor">
+            <a:schemeClr val="lt1"/>
+          </a:fontRef>
+        </p:style>
+        <p:txBody>
+          <a:bodyPr rtlCol="0" anchor="ctr"/>
+          <a:lstStyle/>
+          <a:p>
+            <a:pPr algn="ctr"/>
+          </a:p>
+        </p:txBody>
+      </p:sp>
+      <p:sp>
+        <p:nvSpPr>
+          <p:cNvPr id="12" name="signal_3"/>
+          <p:cNvSpPr txBox="1"/>
+          <p:nvPr/>
+        </p:nvSpPr>
+        <p:spPr>
+          <a:xfrm>
+            <a:off x="8403336" y="1444752"/>
+            <a:ext cx="3246120" cy="4663440"/>
+          </a:xfrm>
+          <a:prstGeom prst="rect">
+            <a:avLst/>
+          </a:prstGeom>
+          <a:noFill/>
+        </p:spPr>
+        <p:txBody>
+          <a:bodyPr wrap="square" anchor="t">
+            <a:spAutoFit/>
+          </a:bodyPr>
+          <a:lstStyle/>
+          <a:p>
+            <a:pPr>
+              <a:spcAft>
+                <a:spcPts val="300"/>
+              </a:spcAft>
+            </a:pPr>
+            <a:r>
+              <a:rPr sz="1600" b="1">
+                <a:solidFill>
+                  <a:srgbClr val="0E2744"/>
+                </a:solidFill>
+                <a:latin typeface="Calibri"/>
+              </a:rPr>
+              <a:t>Two PSP paths are creating two close motions.</a:t>
+            </a:r>
+          </a:p>
+          <a:p>
+            <a:pPr>
+              <a:spcAft>
+                <a:spcPts val="300"/>
+              </a:spcAft>
+            </a:pPr>
+            <a:r>
+              <a:rPr sz="1300" b="0">
+                <a:solidFill>
+                  <a:srgbClr val="1C2A3A"/>
+                </a:solidFill>
+                <a:latin typeface="Calibri"/>
+              </a:rPr>
+              <a:t>Observed: Base Case vs Private Sector (expires end-2026) used as different close paths.</a:t>
+            </a:r>
+          </a:p>
+          <a:p>
+            <a:pPr>
+              <a:spcAft>
+                <a:spcPts val="300"/>
+              </a:spcAft>
+            </a:pPr>
+            <a:r>
+              <a:rPr sz="1300" b="0">
+                <a:solidFill>
+                  <a:srgbClr val="1C2A3A"/>
+                </a:solidFill>
+                <a:latin typeface="Calibri"/>
+              </a:rPr>
+              <a:t>So what: Expiry is a sequencing issue for HQ, not a slogan.</a:t>
+            </a:r>
+          </a:p>
+          <a:p>
+            <a:pPr>
+              <a:spcAft>
+                <a:spcPts val="300"/>
+              </a:spcAft>
+            </a:pPr>
+            <a:r>
+              <a:rPr sz="1300" b="1">
+                <a:solidFill>
+                  <a:srgbClr val="1B7A6E"/>
+                </a:solidFill>
+                <a:latin typeface="Calibri"/>
+              </a:rPr>
+              <a:t>Implication: Do not informal-tweak terms. Confirm eligibility before quoting.</a:t>
+            </a:r>
+          </a:p>
+        </p:txBody>
+      </p:sp>
+      <p:sp>
+        <p:nvSpPr>
+          <p:cNvPr id="13" name="footer_rule"/>
+          <p:cNvSpPr/>
+          <p:nvPr/>
+        </p:nvSpPr>
+        <p:spPr>
+          <a:xfrm>
+            <a:off x="411480" y="6446520"/>
+            <a:ext cx="11365992" cy="18288"/>
+          </a:xfrm>
+          <a:prstGeom prst="rect">
+            <a:avLst/>
+          </a:prstGeom>
+          <a:solidFill>
+            <a:srgbClr val="D8D2C6"/>
+          </a:solidFill>
+          <a:ln>
+            <a:noFill/>
+          </a:ln>
+        </p:spPr>
+        <p:style>
+          <a:lnRef idx="1">
+            <a:schemeClr val="accent1"/>
+          </a:lnRef>
+          <a:fillRef idx="3">
+            <a:schemeClr val="accent1"/>
+          </a:fillRef>
+          <a:effectRef idx="2">
+            <a:schemeClr val="accent1"/>
+          </a:effectRef>
+          <a:fontRef idx="minor">
+            <a:schemeClr val="lt1"/>
+          </a:fontRef>
+        </p:style>
+        <p:txBody>
+          <a:bodyPr rtlCol="0" anchor="ctr"/>
+          <a:lstStyle/>
+          <a:p>
+            <a:pPr algn="ctr"/>
+          </a:p>
+        </p:txBody>
+      </p:sp>
+      <p:sp>
+        <p:nvSpPr>
+          <p:cNvPr id="14" name="footer"/>
+          <p:cNvSpPr txBox="1"/>
+          <p:nvPr/>
+        </p:nvSpPr>
+        <p:spPr>
+          <a:xfrm>
+            <a:off x="411480" y="6473952"/>
+            <a:ext cx="11365992" cy="256032"/>
+          </a:xfrm>
+          <a:prstGeom prst="rect">
+            <a:avLst/>
+          </a:prstGeom>
+          <a:noFill/>
+        </p:spPr>
+        <p:txBody>
+          <a:bodyPr wrap="square" anchor="t">
+            <a:spAutoFit/>
+          </a:bodyPr>
+          <a:lstStyle/>
+          <a:p>
+            <a:pPr>
+              <a:spcAft>
+                <a:spcPts val="300"/>
+              </a:spcAft>
+            </a:pPr>
+            <a:r>
+              <a:rPr sz="1000" b="0">
+                <a:solidFill>
+                  <a:srgbClr val="5B6B7C"/>
+                </a:solidFill>
+                <a:latin typeface="Calibri"/>
+              </a:rPr>
+              <a:t>Patterns only - no named HCPs, patient stories, unpublished dossier data  |  3 / 5</a:t>
+            </a:r>
+          </a:p>
+        </p:txBody>
+      </p:sp>
     </p:spTree>
   </p:cSld>
   <p:clrMapOvr>
@@ -3218,30 +5831,904 @@
         <p:nvPr/>
       </p:nvGrpSpPr>
       <p:grpSpPr/>
-      <p:pic>
-        <p:nvPicPr>
-          <p:cNvPr id="2" name="Picture 1" descr="example-4.png"/>
-          <p:cNvPicPr>
-            <a:picLocks noChangeAspect="1"/>
-          </p:cNvPicPr>
-          <p:nvPr/>
-        </p:nvPicPr>
-        <p:blipFill>
-          <a:blip r:embed="rId2"/>
-          <a:stretch>
-            <a:fillRect/>
-          </a:stretch>
-        </p:blipFill>
+      <p:sp>
+        <p:nvSpPr>
+          <p:cNvPr id="2" name="bg"/>
+          <p:cNvSpPr/>
+          <p:nvPr/>
+        </p:nvSpPr>
         <p:spPr>
           <a:xfrm>
             <a:off x="0" y="0"/>
-            <a:ext cx="12191999" cy="6858000"/>
+            <a:ext cx="12191695" cy="6858000"/>
           </a:xfrm>
           <a:prstGeom prst="rect">
             <a:avLst/>
           </a:prstGeom>
-        </p:spPr>
-      </p:pic>
+          <a:solidFill>
+            <a:srgbClr val="F4F1EA"/>
+          </a:solidFill>
+          <a:ln>
+            <a:noFill/>
+          </a:ln>
+        </p:spPr>
+        <p:style>
+          <a:lnRef idx="1">
+            <a:schemeClr val="accent1"/>
+          </a:lnRef>
+          <a:fillRef idx="3">
+            <a:schemeClr val="accent1"/>
+          </a:fillRef>
+          <a:effectRef idx="2">
+            <a:schemeClr val="accent1"/>
+          </a:effectRef>
+          <a:fontRef idx="minor">
+            <a:schemeClr val="lt1"/>
+          </a:fontRef>
+        </p:style>
+        <p:txBody>
+          <a:bodyPr rtlCol="0" anchor="ctr"/>
+          <a:lstStyle/>
+          <a:p>
+            <a:pPr algn="ctr"/>
+          </a:p>
+        </p:txBody>
+      </p:sp>
+      <p:sp>
+        <p:nvSpPr>
+          <p:cNvPr id="3" name="hdr_left"/>
+          <p:cNvSpPr txBox="1"/>
+          <p:nvPr/>
+        </p:nvSpPr>
+        <p:spPr>
+          <a:xfrm>
+            <a:off x="411480" y="128016"/>
+            <a:ext cx="6400800" cy="274320"/>
+          </a:xfrm>
+          <a:prstGeom prst="rect">
+            <a:avLst/>
+          </a:prstGeom>
+          <a:noFill/>
+        </p:spPr>
+        <p:txBody>
+          <a:bodyPr wrap="square" anchor="t">
+            <a:spAutoFit/>
+          </a:bodyPr>
+          <a:lstStyle/>
+          <a:p>
+            <a:pPr>
+              <a:spcAft>
+                <a:spcPts val="300"/>
+              </a:spcAft>
+            </a:pPr>
+            <a:r>
+              <a:rPr sz="1100" b="1">
+                <a:solidFill>
+                  <a:srgbClr val="0E2744"/>
+                </a:solidFill>
+                <a:latin typeface="Calibri"/>
+              </a:rPr>
+              <a:t>BESREMi | HK PV | PM field pack</a:t>
+            </a:r>
+          </a:p>
+        </p:txBody>
+      </p:sp>
+      <p:sp>
+        <p:nvSpPr>
+          <p:cNvPr id="4" name="hdr_right"/>
+          <p:cNvSpPr txBox="1"/>
+          <p:nvPr/>
+        </p:nvSpPr>
+        <p:spPr>
+          <a:xfrm>
+            <a:off x="6583680" y="128016"/>
+            <a:ext cx="5212080" cy="274320"/>
+          </a:xfrm>
+          <a:prstGeom prst="rect">
+            <a:avLst/>
+          </a:prstGeom>
+          <a:noFill/>
+        </p:spPr>
+        <p:txBody>
+          <a:bodyPr wrap="square" anchor="t">
+            <a:spAutoFit/>
+          </a:bodyPr>
+          <a:lstStyle/>
+          <a:p>
+            <a:pPr algn="r">
+              <a:spcAft>
+                <a:spcPts val="300"/>
+              </a:spcAft>
+            </a:pPr>
+            <a:r>
+              <a:rPr sz="1100" b="1">
+                <a:solidFill>
+                  <a:srgbClr val="5B6B7C"/>
+                </a:solidFill>
+                <a:latin typeface="Calibri"/>
+              </a:rPr>
+              <a:t>Biweekly | [dates] | Mid | Internal | De-identified</a:t>
+            </a:r>
+          </a:p>
+        </p:txBody>
+      </p:sp>
+      <p:sp>
+        <p:nvSpPr>
+          <p:cNvPr id="5" name="kicker"/>
+          <p:cNvSpPr txBox="1"/>
+          <p:nvPr/>
+        </p:nvSpPr>
+        <p:spPr>
+          <a:xfrm>
+            <a:off x="411480" y="420624"/>
+            <a:ext cx="11338560" cy="237744"/>
+          </a:xfrm>
+          <a:prstGeom prst="rect">
+            <a:avLst/>
+          </a:prstGeom>
+          <a:noFill/>
+        </p:spPr>
+        <p:txBody>
+          <a:bodyPr wrap="square" anchor="t">
+            <a:spAutoFit/>
+          </a:bodyPr>
+          <a:lstStyle/>
+          <a:p>
+            <a:pPr>
+              <a:spcAft>
+                <a:spcPts val="300"/>
+              </a:spcAft>
+            </a:pPr>
+            <a:r>
+              <a:rPr sz="1100" b="1">
+                <a:solidFill>
+                  <a:srgbClr val="1B7A6E"/>
+                </a:solidFill>
+                <a:latin typeface="Calibri"/>
+              </a:rPr>
+              <a:t>CONVERSION, NOT COVERAGE</a:t>
+            </a:r>
+          </a:p>
+        </p:txBody>
+      </p:sp>
+      <p:sp>
+        <p:nvSpPr>
+          <p:cNvPr id="6" name="title"/>
+          <p:cNvSpPr txBox="1"/>
+          <p:nvPr/>
+        </p:nvSpPr>
+        <p:spPr>
+          <a:xfrm>
+            <a:off x="411480" y="658368"/>
+            <a:ext cx="11338560" cy="594360"/>
+          </a:xfrm>
+          <a:prstGeom prst="rect">
+            <a:avLst/>
+          </a:prstGeom>
+          <a:noFill/>
+        </p:spPr>
+        <p:txBody>
+          <a:bodyPr wrap="square" anchor="t">
+            <a:spAutoFit/>
+          </a:bodyPr>
+          <a:lstStyle/>
+          <a:p>
+            <a:pPr>
+              <a:spcAft>
+                <a:spcPts val="300"/>
+              </a:spcAft>
+            </a:pPr>
+            <a:r>
+              <a:rPr sz="2600" b="1">
+                <a:solidFill>
+                  <a:srgbClr val="0E2744"/>
+                </a:solidFill>
+                <a:latin typeface="Calibri"/>
+              </a:rPr>
+              <a:t>Where field time dies</a:t>
+            </a:r>
+          </a:p>
+        </p:txBody>
+      </p:sp>
+      <p:sp>
+        <p:nvSpPr>
+          <p:cNvPr id="7" name="funnel_bg"/>
+          <p:cNvSpPr/>
+          <p:nvPr/>
+        </p:nvSpPr>
+        <p:spPr>
+          <a:xfrm>
+            <a:off x="411480" y="1353312"/>
+            <a:ext cx="5394960" cy="4892040"/>
+          </a:xfrm>
+          <a:prstGeom prst="roundRect">
+            <a:avLst/>
+          </a:prstGeom>
+          <a:solidFill>
+            <a:srgbClr val="FFFFFF"/>
+          </a:solidFill>
+          <a:ln>
+            <a:solidFill>
+              <a:srgbClr val="D8D2C6"/>
+            </a:solidFill>
+          </a:ln>
+        </p:spPr>
+        <p:style>
+          <a:lnRef idx="1">
+            <a:schemeClr val="accent1"/>
+          </a:lnRef>
+          <a:fillRef idx="3">
+            <a:schemeClr val="accent1"/>
+          </a:fillRef>
+          <a:effectRef idx="2">
+            <a:schemeClr val="accent1"/>
+          </a:effectRef>
+          <a:fontRef idx="minor">
+            <a:schemeClr val="lt1"/>
+          </a:fontRef>
+        </p:style>
+        <p:txBody>
+          <a:bodyPr rtlCol="0" anchor="ctr"/>
+          <a:lstStyle/>
+          <a:p>
+            <a:pPr algn="ctr"/>
+          </a:p>
+        </p:txBody>
+      </p:sp>
+      <p:sp>
+        <p:nvSpPr>
+          <p:cNvPr id="8" name="funnel_title"/>
+          <p:cNvSpPr txBox="1"/>
+          <p:nvPr/>
+        </p:nvSpPr>
+        <p:spPr>
+          <a:xfrm>
+            <a:off x="557784" y="1444752"/>
+            <a:ext cx="5029200" cy="256032"/>
+          </a:xfrm>
+          <a:prstGeom prst="rect">
+            <a:avLst/>
+          </a:prstGeom>
+          <a:noFill/>
+        </p:spPr>
+        <p:txBody>
+          <a:bodyPr wrap="square" anchor="t">
+            <a:spAutoFit/>
+          </a:bodyPr>
+          <a:lstStyle/>
+          <a:p>
+            <a:pPr>
+              <a:spcAft>
+                <a:spcPts val="300"/>
+              </a:spcAft>
+            </a:pPr>
+            <a:r>
+              <a:rPr sz="1100" b="1">
+                <a:solidFill>
+                  <a:srgbClr val="5B6B7C"/>
+                </a:solidFill>
+                <a:latin typeface="Calibri"/>
+              </a:rPr>
+              <a:t>ACCOUNT MOTION (QUALITATIVE)</a:t>
+            </a:r>
+          </a:p>
+        </p:txBody>
+      </p:sp>
+      <p:sp>
+        <p:nvSpPr>
+          <p:cNvPr id="9" name="funnel_bar_1"/>
+          <p:cNvSpPr/>
+          <p:nvPr/>
+        </p:nvSpPr>
+        <p:spPr>
+          <a:xfrm>
+            <a:off x="640080" y="1874519"/>
+            <a:ext cx="4572000" cy="621792"/>
+          </a:xfrm>
+          <a:prstGeom prst="roundRect">
+            <a:avLst/>
+          </a:prstGeom>
+          <a:solidFill>
+            <a:srgbClr val="0E2744"/>
+          </a:solidFill>
+          <a:ln>
+            <a:noFill/>
+          </a:ln>
+        </p:spPr>
+        <p:style>
+          <a:lnRef idx="1">
+            <a:schemeClr val="accent1"/>
+          </a:lnRef>
+          <a:fillRef idx="3">
+            <a:schemeClr val="accent1"/>
+          </a:fillRef>
+          <a:effectRef idx="2">
+            <a:schemeClr val="accent1"/>
+          </a:effectRef>
+          <a:fontRef idx="minor">
+            <a:schemeClr val="lt1"/>
+          </a:fontRef>
+        </p:style>
+        <p:txBody>
+          <a:bodyPr rtlCol="0" anchor="ctr"/>
+          <a:lstStyle/>
+          <a:p>
+            <a:pPr algn="ctr"/>
+          </a:p>
+        </p:txBody>
+      </p:sp>
+      <p:sp>
+        <p:nvSpPr>
+          <p:cNvPr id="10" name="funnel_txt_1"/>
+          <p:cNvSpPr txBox="1"/>
+          <p:nvPr/>
+        </p:nvSpPr>
+        <p:spPr>
+          <a:xfrm>
+            <a:off x="713232" y="1984247"/>
+            <a:ext cx="4425696" cy="457200"/>
+          </a:xfrm>
+          <a:prstGeom prst="rect">
+            <a:avLst/>
+          </a:prstGeom>
+          <a:noFill/>
+        </p:spPr>
+        <p:txBody>
+          <a:bodyPr wrap="square" anchor="t">
+            <a:spAutoFit/>
+          </a:bodyPr>
+          <a:lstStyle/>
+          <a:p>
+            <a:pPr>
+              <a:spcAft>
+                <a:spcPts val="300"/>
+              </a:spcAft>
+            </a:pPr>
+            <a:r>
+              <a:rPr sz="1300" b="1">
+                <a:solidFill>
+                  <a:srgbClr val="FFFCF7"/>
+                </a:solidFill>
+                <a:latin typeface="Calibri"/>
+              </a:rPr>
+              <a:t>Awareness - holding</a:t>
+            </a:r>
+          </a:p>
+        </p:txBody>
+      </p:sp>
+      <p:sp>
+        <p:nvSpPr>
+          <p:cNvPr id="11" name="funnel_bar_2"/>
+          <p:cNvSpPr/>
+          <p:nvPr/>
+        </p:nvSpPr>
+        <p:spPr>
+          <a:xfrm>
+            <a:off x="1005840" y="2697480"/>
+            <a:ext cx="3840480" cy="621792"/>
+          </a:xfrm>
+          <a:prstGeom prst="roundRect">
+            <a:avLst/>
+          </a:prstGeom>
+          <a:solidFill>
+            <a:srgbClr val="0E2744"/>
+          </a:solidFill>
+          <a:ln>
+            <a:noFill/>
+          </a:ln>
+        </p:spPr>
+        <p:style>
+          <a:lnRef idx="1">
+            <a:schemeClr val="accent1"/>
+          </a:lnRef>
+          <a:fillRef idx="3">
+            <a:schemeClr val="accent1"/>
+          </a:fillRef>
+          <a:effectRef idx="2">
+            <a:schemeClr val="accent1"/>
+          </a:effectRef>
+          <a:fontRef idx="minor">
+            <a:schemeClr val="lt1"/>
+          </a:fontRef>
+        </p:style>
+        <p:txBody>
+          <a:bodyPr rtlCol="0" anchor="ctr"/>
+          <a:lstStyle/>
+          <a:p>
+            <a:pPr algn="ctr"/>
+          </a:p>
+        </p:txBody>
+      </p:sp>
+      <p:sp>
+        <p:nvSpPr>
+          <p:cNvPr id="12" name="funnel_txt_2"/>
+          <p:cNvSpPr txBox="1"/>
+          <p:nvPr/>
+        </p:nvSpPr>
+        <p:spPr>
+          <a:xfrm>
+            <a:off x="1078992" y="2807208"/>
+            <a:ext cx="3694176" cy="457200"/>
+          </a:xfrm>
+          <a:prstGeom prst="rect">
+            <a:avLst/>
+          </a:prstGeom>
+          <a:noFill/>
+        </p:spPr>
+        <p:txBody>
+          <a:bodyPr wrap="square" anchor="t">
+            <a:spAutoFit/>
+          </a:bodyPr>
+          <a:lstStyle/>
+          <a:p>
+            <a:pPr>
+              <a:spcAft>
+                <a:spcPts val="300"/>
+              </a:spcAft>
+            </a:pPr>
+            <a:r>
+              <a:rPr sz="1300" b="1">
+                <a:solidFill>
+                  <a:srgbClr val="FFFCF7"/>
+                </a:solidFill>
+                <a:latin typeface="Calibri"/>
+              </a:rPr>
+              <a:t>Intent - holding</a:t>
+            </a:r>
+          </a:p>
+        </p:txBody>
+      </p:sp>
+      <p:sp>
+        <p:nvSpPr>
+          <p:cNvPr id="13" name="funnel_bar_3"/>
+          <p:cNvSpPr/>
+          <p:nvPr/>
+        </p:nvSpPr>
+        <p:spPr>
+          <a:xfrm>
+            <a:off x="1371600" y="3520440"/>
+            <a:ext cx="3108960" cy="621792"/>
+          </a:xfrm>
+          <a:prstGeom prst="roundRect">
+            <a:avLst/>
+          </a:prstGeom>
+          <a:solidFill>
+            <a:srgbClr val="0E2744"/>
+          </a:solidFill>
+          <a:ln>
+            <a:solidFill>
+              <a:srgbClr val="B8860B"/>
+            </a:solidFill>
+          </a:ln>
+        </p:spPr>
+        <p:style>
+          <a:lnRef idx="1">
+            <a:schemeClr val="accent1"/>
+          </a:lnRef>
+          <a:fillRef idx="3">
+            <a:schemeClr val="accent1"/>
+          </a:fillRef>
+          <a:effectRef idx="2">
+            <a:schemeClr val="accent1"/>
+          </a:effectRef>
+          <a:fontRef idx="minor">
+            <a:schemeClr val="lt1"/>
+          </a:fontRef>
+        </p:style>
+        <p:txBody>
+          <a:bodyPr rtlCol="0" anchor="ctr"/>
+          <a:lstStyle/>
+          <a:p>
+            <a:pPr algn="ctr"/>
+          </a:p>
+        </p:txBody>
+      </p:sp>
+      <p:sp>
+        <p:nvSpPr>
+          <p:cNvPr id="14" name="funnel_txt_3"/>
+          <p:cNvSpPr txBox="1"/>
+          <p:nvPr/>
+        </p:nvSpPr>
+        <p:spPr>
+          <a:xfrm>
+            <a:off x="1444752" y="3630168"/>
+            <a:ext cx="2962656" cy="457200"/>
+          </a:xfrm>
+          <a:prstGeom prst="rect">
+            <a:avLst/>
+          </a:prstGeom>
+          <a:noFill/>
+        </p:spPr>
+        <p:txBody>
+          <a:bodyPr wrap="square" anchor="t">
+            <a:spAutoFit/>
+          </a:bodyPr>
+          <a:lstStyle/>
+          <a:p>
+            <a:pPr>
+              <a:spcAft>
+                <a:spcPts val="300"/>
+              </a:spcAft>
+            </a:pPr>
+            <a:r>
+              <a:rPr sz="1300" b="1">
+                <a:solidFill>
+                  <a:srgbClr val="FFFCF7"/>
+                </a:solidFill>
+                <a:latin typeface="Calibri"/>
+              </a:rPr>
+              <a:t>Initiation - STALL</a:t>
+            </a:r>
+          </a:p>
+        </p:txBody>
+      </p:sp>
+      <p:sp>
+        <p:nvSpPr>
+          <p:cNvPr id="15" name="funnel_bar_4"/>
+          <p:cNvSpPr/>
+          <p:nvPr/>
+        </p:nvSpPr>
+        <p:spPr>
+          <a:xfrm>
+            <a:off x="1828800" y="4343400"/>
+            <a:ext cx="2468880" cy="621792"/>
+          </a:xfrm>
+          <a:prstGeom prst="roundRect">
+            <a:avLst/>
+          </a:prstGeom>
+          <a:solidFill>
+            <a:srgbClr val="0E2744"/>
+          </a:solidFill>
+          <a:ln>
+            <a:noFill/>
+          </a:ln>
+        </p:spPr>
+        <p:style>
+          <a:lnRef idx="1">
+            <a:schemeClr val="accent1"/>
+          </a:lnRef>
+          <a:fillRef idx="3">
+            <a:schemeClr val="accent1"/>
+          </a:fillRef>
+          <a:effectRef idx="2">
+            <a:schemeClr val="accent1"/>
+          </a:effectRef>
+          <a:fontRef idx="minor">
+            <a:schemeClr val="lt1"/>
+          </a:fontRef>
+        </p:style>
+        <p:txBody>
+          <a:bodyPr rtlCol="0" anchor="ctr"/>
+          <a:lstStyle/>
+          <a:p>
+            <a:pPr algn="ctr"/>
+          </a:p>
+        </p:txBody>
+      </p:sp>
+      <p:sp>
+        <p:nvSpPr>
+          <p:cNvPr id="16" name="funnel_txt_4"/>
+          <p:cNvSpPr txBox="1"/>
+          <p:nvPr/>
+        </p:nvSpPr>
+        <p:spPr>
+          <a:xfrm>
+            <a:off x="1901952" y="4453128"/>
+            <a:ext cx="2322576" cy="457200"/>
+          </a:xfrm>
+          <a:prstGeom prst="rect">
+            <a:avLst/>
+          </a:prstGeom>
+          <a:noFill/>
+        </p:spPr>
+        <p:txBody>
+          <a:bodyPr wrap="square" anchor="t">
+            <a:spAutoFit/>
+          </a:bodyPr>
+          <a:lstStyle/>
+          <a:p>
+            <a:pPr>
+              <a:spcAft>
+                <a:spcPts val="300"/>
+              </a:spcAft>
+            </a:pPr>
+            <a:r>
+              <a:rPr sz="1300" b="1">
+                <a:solidFill>
+                  <a:srgbClr val="FFFCF7"/>
+                </a:solidFill>
+                <a:latin typeface="Calibri"/>
+              </a:rPr>
+              <a:t>Persistency - too early</a:t>
+            </a:r>
+          </a:p>
+        </p:txBody>
+      </p:sp>
+      <p:sp>
+        <p:nvSpPr>
+          <p:cNvPr id="17" name="funnel_note"/>
+          <p:cNvSpPr txBox="1"/>
+          <p:nvPr/>
+        </p:nvSpPr>
+        <p:spPr>
+          <a:xfrm>
+            <a:off x="557784" y="5074920"/>
+            <a:ext cx="5029200" cy="502920"/>
+          </a:xfrm>
+          <a:prstGeom prst="rect">
+            <a:avLst/>
+          </a:prstGeom>
+          <a:noFill/>
+        </p:spPr>
+        <p:txBody>
+          <a:bodyPr wrap="square" anchor="t">
+            <a:spAutoFit/>
+          </a:bodyPr>
+          <a:lstStyle/>
+          <a:p>
+            <a:pPr>
+              <a:spcAft>
+                <a:spcPts val="300"/>
+              </a:spcAft>
+            </a:pPr>
+            <a:r>
+              <a:rPr sz="1100" b="0">
+                <a:solidFill>
+                  <a:srgbClr val="5B6B7C"/>
+                </a:solidFill>
+                <a:latin typeface="Calibri"/>
+              </a:rPr>
+              <a:t>Widths are illustrative. Replace with your qualitative read - do not invent counts.</a:t>
+            </a:r>
+          </a:p>
+        </p:txBody>
+      </p:sp>
+      <p:sp>
+        <p:nvSpPr>
+          <p:cNvPr id="18" name="barrier_bg"/>
+          <p:cNvSpPr/>
+          <p:nvPr/>
+        </p:nvSpPr>
+        <p:spPr>
+          <a:xfrm>
+            <a:off x="6126480" y="1353312"/>
+            <a:ext cx="5650992" cy="4892040"/>
+          </a:xfrm>
+          <a:prstGeom prst="roundRect">
+            <a:avLst/>
+          </a:prstGeom>
+          <a:solidFill>
+            <a:srgbClr val="FFFFFF"/>
+          </a:solidFill>
+          <a:ln>
+            <a:solidFill>
+              <a:srgbClr val="D8D2C6"/>
+            </a:solidFill>
+          </a:ln>
+        </p:spPr>
+        <p:style>
+          <a:lnRef idx="1">
+            <a:schemeClr val="accent1"/>
+          </a:lnRef>
+          <a:fillRef idx="3">
+            <a:schemeClr val="accent1"/>
+          </a:fillRef>
+          <a:effectRef idx="2">
+            <a:schemeClr val="accent1"/>
+          </a:effectRef>
+          <a:fontRef idx="minor">
+            <a:schemeClr val="lt1"/>
+          </a:fontRef>
+        </p:style>
+        <p:txBody>
+          <a:bodyPr rtlCol="0" anchor="ctr"/>
+          <a:lstStyle/>
+          <a:p>
+            <a:pPr algn="ctr"/>
+          </a:p>
+        </p:txBody>
+      </p:sp>
+      <p:sp>
+        <p:nvSpPr>
+          <p:cNvPr id="19" name="barriers"/>
+          <p:cNvSpPr txBox="1"/>
+          <p:nvPr/>
+        </p:nvSpPr>
+        <p:spPr>
+          <a:xfrm>
+            <a:off x="6272784" y="1444752"/>
+            <a:ext cx="5349240" cy="4663440"/>
+          </a:xfrm>
+          <a:prstGeom prst="rect">
+            <a:avLst/>
+          </a:prstGeom>
+          <a:noFill/>
+        </p:spPr>
+        <p:txBody>
+          <a:bodyPr wrap="square" anchor="t">
+            <a:spAutoFit/>
+          </a:bodyPr>
+          <a:lstStyle/>
+          <a:p>
+            <a:pPr>
+              <a:spcAft>
+                <a:spcPts val="300"/>
+              </a:spcAft>
+            </a:pPr>
+            <a:r>
+              <a:rPr sz="1100" b="1">
+                <a:solidFill>
+                  <a:srgbClr val="5B6B7C"/>
+                </a:solidFill>
+                <a:latin typeface="Calibri"/>
+              </a:rPr>
+              <a:t>RANKED BARRIERS (MAX 4)</a:t>
+            </a:r>
+          </a:p>
+          <a:p>
+            <a:pPr>
+              <a:spcAft>
+                <a:spcPts val="300"/>
+              </a:spcAft>
+            </a:pPr>
+            <a:r>
+              <a:rPr sz="1400" b="0">
+                <a:solidFill>
+                  <a:srgbClr val="1C2A3A"/>
+                </a:solidFill>
+                <a:latin typeface="Calibri"/>
+              </a:rPr>
+              <a:t>1  Initiation / onboarding after PSP explanation  -&gt; Uptake  | New as the pattern</a:t>
+            </a:r>
+          </a:p>
+          <a:p>
+            <a:pPr>
+              <a:spcAft>
+                <a:spcPts val="300"/>
+              </a:spcAft>
+            </a:pPr>
+            <a:r>
+              <a:rPr sz="1400" b="0">
+                <a:solidFill>
+                  <a:srgbClr val="1C2A3A"/>
+                </a:solidFill>
+                <a:latin typeface="Calibri"/>
+              </a:rPr>
+              <a:t>2  Price vs traditional IFN - lexicon-bound answer only  -&gt; Uptake + compliance  | Unchanged</a:t>
+            </a:r>
+          </a:p>
+          <a:p>
+            <a:pPr>
+              <a:spcAft>
+                <a:spcPts val="300"/>
+              </a:spcAft>
+            </a:pPr>
+            <a:r>
+              <a:rPr sz="1400" b="0">
+                <a:solidFill>
+                  <a:srgbClr val="1C2A3A"/>
+                </a:solidFill>
+                <a:latin typeface="Calibri"/>
+              </a:rPr>
+              <a:t>3  Private Sector PSP clock changing urgency unevenly  -&gt; Access / PSP  | Rising</a:t>
+            </a:r>
+          </a:p>
+          <a:p>
+            <a:pPr>
+              <a:spcAft>
+                <a:spcPts val="300"/>
+              </a:spcAft>
+            </a:pPr>
+            <a:r>
+              <a:rPr sz="1400" b="0">
+                <a:solidFill>
+                  <a:srgbClr val="1C2A3A"/>
+                </a:solidFill>
+                <a:latin typeface="Calibri"/>
+              </a:rPr>
+              <a:t>4  [Fourth barrier or delete row]</a:t>
+            </a:r>
+          </a:p>
+          <a:p>
+            <a:pPr>
+              <a:spcAft>
+                <a:spcPts val="300"/>
+              </a:spcAft>
+            </a:pPr>
+            <a:r>
+              <a:rPr sz="1400" b="1">
+                <a:solidFill>
+                  <a:srgbClr val="0E2744"/>
+                </a:solidFill>
+                <a:latin typeface="Calibri"/>
+              </a:rPr>
+              <a:t>Moved this cycle: Stopped spreading coverage. Next two weeks: initiation checklist on the priority-account list (titles only; no HCP names on this slide).</a:t>
+            </a:r>
+          </a:p>
+        </p:txBody>
+      </p:sp>
+      <p:sp>
+        <p:nvSpPr>
+          <p:cNvPr id="20" name="footer_rule"/>
+          <p:cNvSpPr/>
+          <p:nvPr/>
+        </p:nvSpPr>
+        <p:spPr>
+          <a:xfrm>
+            <a:off x="411480" y="6446520"/>
+            <a:ext cx="11365992" cy="18288"/>
+          </a:xfrm>
+          <a:prstGeom prst="rect">
+            <a:avLst/>
+          </a:prstGeom>
+          <a:solidFill>
+            <a:srgbClr val="D8D2C6"/>
+          </a:solidFill>
+          <a:ln>
+            <a:noFill/>
+          </a:ln>
+        </p:spPr>
+        <p:style>
+          <a:lnRef idx="1">
+            <a:schemeClr val="accent1"/>
+          </a:lnRef>
+          <a:fillRef idx="3">
+            <a:schemeClr val="accent1"/>
+          </a:fillRef>
+          <a:effectRef idx="2">
+            <a:schemeClr val="accent1"/>
+          </a:effectRef>
+          <a:fontRef idx="minor">
+            <a:schemeClr val="lt1"/>
+          </a:fontRef>
+        </p:style>
+        <p:txBody>
+          <a:bodyPr rtlCol="0" anchor="ctr"/>
+          <a:lstStyle/>
+          <a:p>
+            <a:pPr algn="ctr"/>
+          </a:p>
+        </p:txBody>
+      </p:sp>
+      <p:sp>
+        <p:nvSpPr>
+          <p:cNvPr id="21" name="footer"/>
+          <p:cNvSpPr txBox="1"/>
+          <p:nvPr/>
+        </p:nvSpPr>
+        <p:spPr>
+          <a:xfrm>
+            <a:off x="411480" y="6473952"/>
+            <a:ext cx="11365992" cy="256032"/>
+          </a:xfrm>
+          <a:prstGeom prst="rect">
+            <a:avLst/>
+          </a:prstGeom>
+          <a:noFill/>
+        </p:spPr>
+        <p:txBody>
+          <a:bodyPr wrap="square" anchor="t">
+            <a:spAutoFit/>
+          </a:bodyPr>
+          <a:lstStyle/>
+          <a:p>
+            <a:pPr>
+              <a:spcAft>
+                <a:spcPts val="300"/>
+              </a:spcAft>
+            </a:pPr>
+            <a:r>
+              <a:rPr sz="1000" b="0">
+                <a:solidFill>
+                  <a:srgbClr val="5B6B7C"/>
+                </a:solidFill>
+                <a:latin typeface="Calibri"/>
+              </a:rPr>
+              <a:t>Patterns only - no named HCPs, patient stories, unpublished dossier data  |  4 / 5</a:t>
+            </a:r>
+          </a:p>
+        </p:txBody>
+      </p:sp>
     </p:spTree>
   </p:cSld>
   <p:clrMapOvr>
@@ -3260,30 +6747,967 @@
         <p:nvPr/>
       </p:nvGrpSpPr>
       <p:grpSpPr/>
-      <p:pic>
-        <p:nvPicPr>
-          <p:cNvPr id="2" name="Picture 1" descr="example-5.png"/>
-          <p:cNvPicPr>
-            <a:picLocks noChangeAspect="1"/>
-          </p:cNvPicPr>
-          <p:nvPr/>
-        </p:nvPicPr>
-        <p:blipFill>
-          <a:blip r:embed="rId2"/>
-          <a:stretch>
-            <a:fillRect/>
-          </a:stretch>
-        </p:blipFill>
+      <p:sp>
+        <p:nvSpPr>
+          <p:cNvPr id="2" name="bg"/>
+          <p:cNvSpPr/>
+          <p:nvPr/>
+        </p:nvSpPr>
         <p:spPr>
           <a:xfrm>
             <a:off x="0" y="0"/>
-            <a:ext cx="12191999" cy="6858000"/>
+            <a:ext cx="12191695" cy="6858000"/>
           </a:xfrm>
           <a:prstGeom prst="rect">
             <a:avLst/>
           </a:prstGeom>
-        </p:spPr>
-      </p:pic>
+          <a:solidFill>
+            <a:srgbClr val="F4F1EA"/>
+          </a:solidFill>
+          <a:ln>
+            <a:noFill/>
+          </a:ln>
+        </p:spPr>
+        <p:style>
+          <a:lnRef idx="1">
+            <a:schemeClr val="accent1"/>
+          </a:lnRef>
+          <a:fillRef idx="3">
+            <a:schemeClr val="accent1"/>
+          </a:fillRef>
+          <a:effectRef idx="2">
+            <a:schemeClr val="accent1"/>
+          </a:effectRef>
+          <a:fontRef idx="minor">
+            <a:schemeClr val="lt1"/>
+          </a:fontRef>
+        </p:style>
+        <p:txBody>
+          <a:bodyPr rtlCol="0" anchor="ctr"/>
+          <a:lstStyle/>
+          <a:p>
+            <a:pPr algn="ctr"/>
+          </a:p>
+        </p:txBody>
+      </p:sp>
+      <p:sp>
+        <p:nvSpPr>
+          <p:cNvPr id="3" name="hdr_left"/>
+          <p:cNvSpPr txBox="1"/>
+          <p:nvPr/>
+        </p:nvSpPr>
+        <p:spPr>
+          <a:xfrm>
+            <a:off x="411480" y="128016"/>
+            <a:ext cx="6400800" cy="274320"/>
+          </a:xfrm>
+          <a:prstGeom prst="rect">
+            <a:avLst/>
+          </a:prstGeom>
+          <a:noFill/>
+        </p:spPr>
+        <p:txBody>
+          <a:bodyPr wrap="square" anchor="t">
+            <a:spAutoFit/>
+          </a:bodyPr>
+          <a:lstStyle/>
+          <a:p>
+            <a:pPr>
+              <a:spcAft>
+                <a:spcPts val="300"/>
+              </a:spcAft>
+            </a:pPr>
+            <a:r>
+              <a:rPr sz="1100" b="1">
+                <a:solidFill>
+                  <a:srgbClr val="0E2744"/>
+                </a:solidFill>
+                <a:latin typeface="Calibri"/>
+              </a:rPr>
+              <a:t>BESREMi | HK PV | PM field pack</a:t>
+            </a:r>
+          </a:p>
+        </p:txBody>
+      </p:sp>
+      <p:sp>
+        <p:nvSpPr>
+          <p:cNvPr id="4" name="hdr_right"/>
+          <p:cNvSpPr txBox="1"/>
+          <p:nvPr/>
+        </p:nvSpPr>
+        <p:spPr>
+          <a:xfrm>
+            <a:off x="6583680" y="128016"/>
+            <a:ext cx="5212080" cy="274320"/>
+          </a:xfrm>
+          <a:prstGeom prst="rect">
+            <a:avLst/>
+          </a:prstGeom>
+          <a:noFill/>
+        </p:spPr>
+        <p:txBody>
+          <a:bodyPr wrap="square" anchor="t">
+            <a:spAutoFit/>
+          </a:bodyPr>
+          <a:lstStyle/>
+          <a:p>
+            <a:pPr algn="r">
+              <a:spcAft>
+                <a:spcPts val="300"/>
+              </a:spcAft>
+            </a:pPr>
+            <a:r>
+              <a:rPr sz="1100" b="1">
+                <a:solidFill>
+                  <a:srgbClr val="5B6B7C"/>
+                </a:solidFill>
+                <a:latin typeface="Calibri"/>
+              </a:rPr>
+              <a:t>Biweekly | [dates] | Mid | Internal | De-identified</a:t>
+            </a:r>
+          </a:p>
+        </p:txBody>
+      </p:sp>
+      <p:sp>
+        <p:nvSpPr>
+          <p:cNvPr id="5" name="kicker"/>
+          <p:cNvSpPr txBox="1"/>
+          <p:nvPr/>
+        </p:nvSpPr>
+        <p:spPr>
+          <a:xfrm>
+            <a:off x="411480" y="420624"/>
+            <a:ext cx="11338560" cy="237744"/>
+          </a:xfrm>
+          <a:prstGeom prst="rect">
+            <a:avLst/>
+          </a:prstGeom>
+          <a:noFill/>
+        </p:spPr>
+        <p:txBody>
+          <a:bodyPr wrap="square" anchor="t">
+            <a:spAutoFit/>
+          </a:bodyPr>
+          <a:lstStyle/>
+          <a:p>
+            <a:pPr>
+              <a:spcAft>
+                <a:spcPts val="300"/>
+              </a:spcAft>
+            </a:pPr>
+            <a:r>
+              <a:rPr sz="1100" b="1">
+                <a:solidFill>
+                  <a:srgbClr val="1B7A6E"/>
+                </a:solidFill>
+                <a:latin typeface="Calibri"/>
+              </a:rPr>
+              <a:t>DECISION PAGE</a:t>
+            </a:r>
+          </a:p>
+        </p:txBody>
+      </p:sp>
+      <p:sp>
+        <p:nvSpPr>
+          <p:cNvPr id="6" name="title"/>
+          <p:cNvSpPr txBox="1"/>
+          <p:nvPr/>
+        </p:nvSpPr>
+        <p:spPr>
+          <a:xfrm>
+            <a:off x="411480" y="658368"/>
+            <a:ext cx="11338560" cy="594360"/>
+          </a:xfrm>
+          <a:prstGeom prst="rect">
+            <a:avLst/>
+          </a:prstGeom>
+          <a:noFill/>
+        </p:spPr>
+        <p:txBody>
+          <a:bodyPr wrap="square" anchor="t">
+            <a:spAutoFit/>
+          </a:bodyPr>
+          <a:lstStyle/>
+          <a:p>
+            <a:pPr>
+              <a:spcAft>
+                <a:spcPts val="300"/>
+              </a:spcAft>
+            </a:pPr>
+            <a:r>
+              <a:rPr sz="2600" b="1">
+                <a:solidFill>
+                  <a:srgbClr val="0E2744"/>
+                </a:solidFill>
+                <a:latin typeface="Calibri"/>
+              </a:rPr>
+              <a:t>Options, risks, and the HQ ask</a:t>
+            </a:r>
+          </a:p>
+        </p:txBody>
+      </p:sp>
+      <p:sp>
+        <p:nvSpPr>
+          <p:cNvPr id="7" name="opt_bg_1"/>
+          <p:cNvSpPr/>
+          <p:nvPr/>
+        </p:nvSpPr>
+        <p:spPr>
+          <a:xfrm>
+            <a:off x="411480" y="1298448"/>
+            <a:ext cx="3520440" cy="1874519"/>
+          </a:xfrm>
+          <a:prstGeom prst="roundRect">
+            <a:avLst/>
+          </a:prstGeom>
+          <a:solidFill>
+            <a:srgbClr val="FFFFFF"/>
+          </a:solidFill>
+          <a:ln>
+            <a:solidFill>
+              <a:srgbClr val="D8D2C6"/>
+            </a:solidFill>
+          </a:ln>
+        </p:spPr>
+        <p:style>
+          <a:lnRef idx="1">
+            <a:schemeClr val="accent1"/>
+          </a:lnRef>
+          <a:fillRef idx="3">
+            <a:schemeClr val="accent1"/>
+          </a:fillRef>
+          <a:effectRef idx="2">
+            <a:schemeClr val="accent1"/>
+          </a:effectRef>
+          <a:fontRef idx="minor">
+            <a:schemeClr val="lt1"/>
+          </a:fontRef>
+        </p:style>
+        <p:txBody>
+          <a:bodyPr rtlCol="0" anchor="ctr"/>
+          <a:lstStyle/>
+          <a:p>
+            <a:pPr algn="ctr"/>
+          </a:p>
+        </p:txBody>
+      </p:sp>
+      <p:sp>
+        <p:nvSpPr>
+          <p:cNvPr id="8" name="option_1"/>
+          <p:cNvSpPr txBox="1"/>
+          <p:nvPr/>
+        </p:nvSpPr>
+        <p:spPr>
+          <a:xfrm>
+            <a:off x="539496" y="1371600"/>
+            <a:ext cx="3246120" cy="1691640"/>
+          </a:xfrm>
+          <a:prstGeom prst="rect">
+            <a:avLst/>
+          </a:prstGeom>
+          <a:noFill/>
+        </p:spPr>
+        <p:txBody>
+          <a:bodyPr wrap="square" anchor="t">
+            <a:spAutoFit/>
+          </a:bodyPr>
+          <a:lstStyle/>
+          <a:p>
+            <a:pPr>
+              <a:spcAft>
+                <a:spcPts val="300"/>
+              </a:spcAft>
+            </a:pPr>
+            <a:r>
+              <a:rPr sz="1000" b="1">
+                <a:solidFill>
+                  <a:srgbClr val="1B7A6E"/>
+                </a:solidFill>
+                <a:latin typeface="Calibri"/>
+              </a:rPr>
+              <a:t>NOT RECOMMENDED</a:t>
+            </a:r>
+          </a:p>
+          <a:p>
+            <a:pPr>
+              <a:spcAft>
+                <a:spcPts val="300"/>
+              </a:spcAft>
+            </a:pPr>
+            <a:r>
+              <a:rPr sz="1500" b="1">
+                <a:solidFill>
+                  <a:srgbClr val="0E2744"/>
+                </a:solidFill>
+                <a:latin typeface="Calibri"/>
+              </a:rPr>
+              <a:t>A. Keep activity reports</a:t>
+            </a:r>
+          </a:p>
+          <a:p>
+            <a:pPr>
+              <a:spcAft>
+                <a:spcPts val="300"/>
+              </a:spcAft>
+            </a:pPr>
+            <a:r>
+              <a:rPr sz="1200" b="0">
+                <a:solidFill>
+                  <a:srgbClr val="1C2A3A"/>
+                </a:solidFill>
+                <a:latin typeface="Calibri"/>
+              </a:rPr>
+              <a:t>Visit counts and trip notes. Easy to write; HQ cannot see the thesis.</a:t>
+            </a:r>
+          </a:p>
+        </p:txBody>
+      </p:sp>
+      <p:sp>
+        <p:nvSpPr>
+          <p:cNvPr id="9" name="opt_bg_2"/>
+          <p:cNvSpPr/>
+          <p:nvPr/>
+        </p:nvSpPr>
+        <p:spPr>
+          <a:xfrm>
+            <a:off x="4343400" y="1298448"/>
+            <a:ext cx="3520440" cy="1874519"/>
+          </a:xfrm>
+          <a:prstGeom prst="roundRect">
+            <a:avLst/>
+          </a:prstGeom>
+          <a:solidFill>
+            <a:srgbClr val="E4F3EF"/>
+          </a:solidFill>
+          <a:ln>
+            <a:solidFill>
+              <a:srgbClr val="D8D2C6"/>
+            </a:solidFill>
+          </a:ln>
+        </p:spPr>
+        <p:style>
+          <a:lnRef idx="1">
+            <a:schemeClr val="accent1"/>
+          </a:lnRef>
+          <a:fillRef idx="3">
+            <a:schemeClr val="accent1"/>
+          </a:fillRef>
+          <a:effectRef idx="2">
+            <a:schemeClr val="accent1"/>
+          </a:effectRef>
+          <a:fontRef idx="minor">
+            <a:schemeClr val="lt1"/>
+          </a:fontRef>
+        </p:style>
+        <p:txBody>
+          <a:bodyPr rtlCol="0" anchor="ctr"/>
+          <a:lstStyle/>
+          <a:p>
+            <a:pPr algn="ctr"/>
+          </a:p>
+        </p:txBody>
+      </p:sp>
+      <p:sp>
+        <p:nvSpPr>
+          <p:cNvPr id="10" name="option_2"/>
+          <p:cNvSpPr txBox="1"/>
+          <p:nvPr/>
+        </p:nvSpPr>
+        <p:spPr>
+          <a:xfrm>
+            <a:off x="4471416" y="1371600"/>
+            <a:ext cx="3246120" cy="1691640"/>
+          </a:xfrm>
+          <a:prstGeom prst="rect">
+            <a:avLst/>
+          </a:prstGeom>
+          <a:noFill/>
+        </p:spPr>
+        <p:txBody>
+          <a:bodyPr wrap="square" anchor="t">
+            <a:spAutoFit/>
+          </a:bodyPr>
+          <a:lstStyle/>
+          <a:p>
+            <a:pPr>
+              <a:spcAft>
+                <a:spcPts val="300"/>
+              </a:spcAft>
+            </a:pPr>
+            <a:r>
+              <a:rPr sz="1000" b="1">
+                <a:solidFill>
+                  <a:srgbClr val="1B7A6E"/>
+                </a:solidFill>
+                <a:latin typeface="Calibri"/>
+              </a:rPr>
+              <a:t>RECOMMENDED</a:t>
+            </a:r>
+          </a:p>
+          <a:p>
+            <a:pPr>
+              <a:spcAft>
+                <a:spcPts val="300"/>
+              </a:spcAft>
+            </a:pPr>
+            <a:r>
+              <a:rPr sz="1500" b="1">
+                <a:solidFill>
+                  <a:srgbClr val="0E2744"/>
+                </a:solidFill>
+                <a:latin typeface="Calibri"/>
+              </a:rPr>
+              <a:t>B. Signal -&gt; implication -&gt; ask</a:t>
+            </a:r>
+          </a:p>
+          <a:p>
+            <a:pPr>
+              <a:spcAft>
+                <a:spcPts val="300"/>
+              </a:spcAft>
+            </a:pPr>
+            <a:r>
+              <a:rPr sz="1200" b="0">
+                <a:solidFill>
+                  <a:srgbClr val="1C2A3A"/>
+                </a:solidFill>
+                <a:latin typeface="Calibri"/>
+              </a:rPr>
+              <a:t>This pack. Three patterns, RAG vs plan, one decision date.</a:t>
+            </a:r>
+          </a:p>
+        </p:txBody>
+      </p:sp>
+      <p:sp>
+        <p:nvSpPr>
+          <p:cNvPr id="11" name="opt_bg_3"/>
+          <p:cNvSpPr/>
+          <p:nvPr/>
+        </p:nvSpPr>
+        <p:spPr>
+          <a:xfrm>
+            <a:off x="8275320" y="1298448"/>
+            <a:ext cx="3520440" cy="1874519"/>
+          </a:xfrm>
+          <a:prstGeom prst="roundRect">
+            <a:avLst/>
+          </a:prstGeom>
+          <a:solidFill>
+            <a:srgbClr val="FFFFFF"/>
+          </a:solidFill>
+          <a:ln>
+            <a:solidFill>
+              <a:srgbClr val="D8D2C6"/>
+            </a:solidFill>
+          </a:ln>
+        </p:spPr>
+        <p:style>
+          <a:lnRef idx="1">
+            <a:schemeClr val="accent1"/>
+          </a:lnRef>
+          <a:fillRef idx="3">
+            <a:schemeClr val="accent1"/>
+          </a:fillRef>
+          <a:effectRef idx="2">
+            <a:schemeClr val="accent1"/>
+          </a:effectRef>
+          <a:fontRef idx="minor">
+            <a:schemeClr val="lt1"/>
+          </a:fontRef>
+        </p:style>
+        <p:txBody>
+          <a:bodyPr rtlCol="0" anchor="ctr"/>
+          <a:lstStyle/>
+          <a:p>
+            <a:pPr algn="ctr"/>
+          </a:p>
+        </p:txBody>
+      </p:sp>
+      <p:sp>
+        <p:nvSpPr>
+          <p:cNvPr id="12" name="option_3"/>
+          <p:cNvSpPr txBox="1"/>
+          <p:nvPr/>
+        </p:nvSpPr>
+        <p:spPr>
+          <a:xfrm>
+            <a:off x="8403336" y="1371600"/>
+            <a:ext cx="3246120" cy="1691640"/>
+          </a:xfrm>
+          <a:prstGeom prst="rect">
+            <a:avLst/>
+          </a:prstGeom>
+          <a:noFill/>
+        </p:spPr>
+        <p:txBody>
+          <a:bodyPr wrap="square" anchor="t">
+            <a:spAutoFit/>
+          </a:bodyPr>
+          <a:lstStyle/>
+          <a:p>
+            <a:pPr>
+              <a:spcAft>
+                <a:spcPts val="300"/>
+              </a:spcAft>
+            </a:pPr>
+            <a:r>
+              <a:rPr sz="1000" b="1">
+                <a:solidFill>
+                  <a:srgbClr val="1B7A6E"/>
+                </a:solidFill>
+                <a:latin typeface="Calibri"/>
+              </a:rPr>
+              <a:t>NOT RECOMMENDED</a:t>
+            </a:r>
+          </a:p>
+          <a:p>
+            <a:pPr>
+              <a:spcAft>
+                <a:spcPts val="300"/>
+              </a:spcAft>
+            </a:pPr>
+            <a:r>
+              <a:rPr sz="1500" b="1">
+                <a:solidFill>
+                  <a:srgbClr val="0E2744"/>
+                </a:solidFill>
+                <a:latin typeface="Calibri"/>
+              </a:rPr>
+              <a:t>C. CRM dump</a:t>
+            </a:r>
+          </a:p>
+          <a:p>
+            <a:pPr>
+              <a:spcAft>
+                <a:spcPts val="300"/>
+              </a:spcAft>
+            </a:pPr>
+            <a:r>
+              <a:rPr sz="1200" b="0">
+                <a:solidFill>
+                  <a:srgbClr val="1C2A3A"/>
+                </a:solidFill>
+                <a:latin typeface="Calibri"/>
+              </a:rPr>
+              <a:t>Looks rigorous, usually unreadable, often too sensitive to forward.</a:t>
+            </a:r>
+          </a:p>
+        </p:txBody>
+      </p:sp>
+      <p:sp>
+        <p:nvSpPr>
+          <p:cNvPr id="13" name="premortem_bg"/>
+          <p:cNvSpPr/>
+          <p:nvPr/>
+        </p:nvSpPr>
+        <p:spPr>
+          <a:xfrm>
+            <a:off x="411480" y="3310128"/>
+            <a:ext cx="5532120" cy="1143000"/>
+          </a:xfrm>
+          <a:prstGeom prst="roundRect">
+            <a:avLst/>
+          </a:prstGeom>
+          <a:solidFill>
+            <a:srgbClr val="FFFFFF"/>
+          </a:solidFill>
+          <a:ln>
+            <a:solidFill>
+              <a:srgbClr val="D8D2C6"/>
+            </a:solidFill>
+          </a:ln>
+        </p:spPr>
+        <p:style>
+          <a:lnRef idx="1">
+            <a:schemeClr val="accent1"/>
+          </a:lnRef>
+          <a:fillRef idx="3">
+            <a:schemeClr val="accent1"/>
+          </a:fillRef>
+          <a:effectRef idx="2">
+            <a:schemeClr val="accent1"/>
+          </a:effectRef>
+          <a:fontRef idx="minor">
+            <a:schemeClr val="lt1"/>
+          </a:fontRef>
+        </p:style>
+        <p:txBody>
+          <a:bodyPr rtlCol="0" anchor="ctr"/>
+          <a:lstStyle/>
+          <a:p>
+            <a:pPr algn="ctr"/>
+          </a:p>
+        </p:txBody>
+      </p:sp>
+      <p:sp>
+        <p:nvSpPr>
+          <p:cNvPr id="14" name="risk_bg"/>
+          <p:cNvSpPr/>
+          <p:nvPr/>
+        </p:nvSpPr>
+        <p:spPr>
+          <a:xfrm>
+            <a:off x="6245352" y="3310128"/>
+            <a:ext cx="5532120" cy="1143000"/>
+          </a:xfrm>
+          <a:prstGeom prst="roundRect">
+            <a:avLst/>
+          </a:prstGeom>
+          <a:solidFill>
+            <a:srgbClr val="FFFFFF"/>
+          </a:solidFill>
+          <a:ln>
+            <a:solidFill>
+              <a:srgbClr val="D8D2C6"/>
+            </a:solidFill>
+          </a:ln>
+        </p:spPr>
+        <p:style>
+          <a:lnRef idx="1">
+            <a:schemeClr val="accent1"/>
+          </a:lnRef>
+          <a:fillRef idx="3">
+            <a:schemeClr val="accent1"/>
+          </a:fillRef>
+          <a:effectRef idx="2">
+            <a:schemeClr val="accent1"/>
+          </a:effectRef>
+          <a:fontRef idx="minor">
+            <a:schemeClr val="lt1"/>
+          </a:fontRef>
+        </p:style>
+        <p:txBody>
+          <a:bodyPr rtlCol="0" anchor="ctr"/>
+          <a:lstStyle/>
+          <a:p>
+            <a:pPr algn="ctr"/>
+          </a:p>
+        </p:txBody>
+      </p:sp>
+      <p:sp>
+        <p:nvSpPr>
+          <p:cNvPr id="15" name="premortem"/>
+          <p:cNvSpPr txBox="1"/>
+          <p:nvPr/>
+        </p:nvSpPr>
+        <p:spPr>
+          <a:xfrm>
+            <a:off x="539496" y="3383280"/>
+            <a:ext cx="5257800" cy="960120"/>
+          </a:xfrm>
+          <a:prstGeom prst="rect">
+            <a:avLst/>
+          </a:prstGeom>
+          <a:noFill/>
+        </p:spPr>
+        <p:txBody>
+          <a:bodyPr wrap="square" anchor="t">
+            <a:spAutoFit/>
+          </a:bodyPr>
+          <a:lstStyle/>
+          <a:p>
+            <a:pPr>
+              <a:spcAft>
+                <a:spcPts val="300"/>
+              </a:spcAft>
+            </a:pPr>
+            <a:r>
+              <a:rPr sz="1100" b="1">
+                <a:solidFill>
+                  <a:srgbClr val="5B6B7C"/>
+                </a:solidFill>
+                <a:latin typeface="Calibri"/>
+              </a:rPr>
+              <a:t>PRE-MORTEM</a:t>
+            </a:r>
+          </a:p>
+          <a:p>
+            <a:pPr>
+              <a:spcAft>
+                <a:spcPts val="300"/>
+              </a:spcAft>
+            </a:pPr>
+            <a:r>
+              <a:rPr sz="1300" b="0">
+                <a:solidFill>
+                  <a:srgbClr val="1C2A3A"/>
+                </a:solidFill>
+                <a:latin typeface="Calibri"/>
+              </a:rPr>
+              <a:t>If this fails: someone still scores the team on call volume, so activity theatre returns.</a:t>
+            </a:r>
+          </a:p>
+        </p:txBody>
+      </p:sp>
+      <p:sp>
+        <p:nvSpPr>
+          <p:cNvPr id="16" name="share_risk"/>
+          <p:cNvSpPr txBox="1"/>
+          <p:nvPr/>
+        </p:nvSpPr>
+        <p:spPr>
+          <a:xfrm>
+            <a:off x="6373368" y="3383280"/>
+            <a:ext cx="5257800" cy="960120"/>
+          </a:xfrm>
+          <a:prstGeom prst="rect">
+            <a:avLst/>
+          </a:prstGeom>
+          <a:noFill/>
+        </p:spPr>
+        <p:txBody>
+          <a:bodyPr wrap="square" anchor="t">
+            <a:spAutoFit/>
+          </a:bodyPr>
+          <a:lstStyle/>
+          <a:p>
+            <a:pPr>
+              <a:spcAft>
+                <a:spcPts val="300"/>
+              </a:spcAft>
+            </a:pPr>
+            <a:r>
+              <a:rPr sz="1100" b="1">
+                <a:solidFill>
+                  <a:srgbClr val="5B6B7C"/>
+                </a:solidFill>
+                <a:latin typeface="Calibri"/>
+              </a:rPr>
+              <a:t>SHAREABLE-PACK RISK</a:t>
+            </a:r>
+          </a:p>
+          <a:p>
+            <a:pPr>
+              <a:spcAft>
+                <a:spcPts val="300"/>
+              </a:spcAft>
+            </a:pPr>
+            <a:r>
+              <a:rPr sz="1300" b="0">
+                <a:solidFill>
+                  <a:srgbClr val="1C2A3A"/>
+                </a:solidFill>
+                <a:latin typeface="Calibri"/>
+              </a:rPr>
+              <a:t>A named KOL or patient-adjacent story leaks into a forwardable deck.</a:t>
+            </a:r>
+          </a:p>
+        </p:txBody>
+      </p:sp>
+      <p:sp>
+        <p:nvSpPr>
+          <p:cNvPr id="17" name="actions_bg"/>
+          <p:cNvSpPr/>
+          <p:nvPr/>
+        </p:nvSpPr>
+        <p:spPr>
+          <a:xfrm>
+            <a:off x="411480" y="4617720"/>
+            <a:ext cx="11365992" cy="1691640"/>
+          </a:xfrm>
+          <a:prstGeom prst="roundRect">
+            <a:avLst/>
+          </a:prstGeom>
+          <a:solidFill>
+            <a:srgbClr val="FFFFFF"/>
+          </a:solidFill>
+          <a:ln>
+            <a:solidFill>
+              <a:srgbClr val="D8D2C6"/>
+            </a:solidFill>
+          </a:ln>
+        </p:spPr>
+        <p:style>
+          <a:lnRef idx="1">
+            <a:schemeClr val="accent1"/>
+          </a:lnRef>
+          <a:fillRef idx="3">
+            <a:schemeClr val="accent1"/>
+          </a:fillRef>
+          <a:effectRef idx="2">
+            <a:schemeClr val="accent1"/>
+          </a:effectRef>
+          <a:fontRef idx="minor">
+            <a:schemeClr val="lt1"/>
+          </a:fontRef>
+        </p:style>
+        <p:txBody>
+          <a:bodyPr rtlCol="0" anchor="ctr"/>
+          <a:lstStyle/>
+          <a:p>
+            <a:pPr algn="ctr"/>
+          </a:p>
+        </p:txBody>
+      </p:sp>
+      <p:sp>
+        <p:nvSpPr>
+          <p:cNvPr id="18" name="actions"/>
+          <p:cNvSpPr txBox="1"/>
+          <p:nvPr/>
+        </p:nvSpPr>
+        <p:spPr>
+          <a:xfrm>
+            <a:off x="539496" y="4681728"/>
+            <a:ext cx="11064240" cy="1554480"/>
+          </a:xfrm>
+          <a:prstGeom prst="rect">
+            <a:avLst/>
+          </a:prstGeom>
+          <a:noFill/>
+        </p:spPr>
+        <p:txBody>
+          <a:bodyPr wrap="square" anchor="t">
+            <a:spAutoFit/>
+          </a:bodyPr>
+          <a:lstStyle/>
+          <a:p>
+            <a:pPr>
+              <a:spcAft>
+                <a:spcPts val="300"/>
+              </a:spcAft>
+            </a:pPr>
+            <a:r>
+              <a:rPr sz="1100" b="1">
+                <a:solidFill>
+                  <a:srgbClr val="5B6B7C"/>
+                </a:solidFill>
+                <a:latin typeface="Calibri"/>
+              </a:rPr>
+              <a:t>NEXT ACTIONS  |  role + date, not names</a:t>
+            </a:r>
+          </a:p>
+          <a:p>
+            <a:pPr>
+              <a:spcAft>
+                <a:spcPts val="300"/>
+              </a:spcAft>
+            </a:pPr>
+            <a:r>
+              <a:rPr sz="1400" b="0">
+                <a:solidFill>
+                  <a:srgbClr val="1C2A3A"/>
+                </a:solidFill>
+                <a:latin typeface="Calibri"/>
+              </a:rPr>
+              <a:t>1  Rewrite last trip report into this 5-slide pack; strip names  |  PM  |  This week</a:t>
+            </a:r>
+          </a:p>
+          <a:p>
+            <a:pPr>
+              <a:spcAft>
+                <a:spcPts val="300"/>
+              </a:spcAft>
+            </a:pPr>
+            <a:r>
+              <a:rPr sz="1400" b="0">
+                <a:solidFill>
+                  <a:srgbClr val="1C2A3A"/>
+                </a:solidFill>
+                <a:latin typeface="Calibri"/>
+              </a:rPr>
+              <a:t>2  Lock RAG definitions with GM (uptake / formulary / compliance)  |  PM + GM  |  Next HQ cycle</a:t>
+            </a:r>
+          </a:p>
+          <a:p>
+            <a:pPr>
+              <a:spcAft>
+                <a:spcPts val="300"/>
+              </a:spcAft>
+            </a:pPr>
+            <a:r>
+              <a:rPr sz="1400" b="0">
+                <a:solidFill>
+                  <a:srgbClr val="1C2A3A"/>
+                </a:solidFill>
+                <a:latin typeface="Calibri"/>
+              </a:rPr>
+              <a:t>3  Compliance pass: no ET/MF promotion, no uncleared claims  |  PM + Legal/Compliance  |  Before send</a:t>
+            </a:r>
+          </a:p>
+        </p:txBody>
+      </p:sp>
+      <p:sp>
+        <p:nvSpPr>
+          <p:cNvPr id="19" name="footer_rule"/>
+          <p:cNvSpPr/>
+          <p:nvPr/>
+        </p:nvSpPr>
+        <p:spPr>
+          <a:xfrm>
+            <a:off x="411480" y="6446520"/>
+            <a:ext cx="11365992" cy="18288"/>
+          </a:xfrm>
+          <a:prstGeom prst="rect">
+            <a:avLst/>
+          </a:prstGeom>
+          <a:solidFill>
+            <a:srgbClr val="D8D2C6"/>
+          </a:solidFill>
+          <a:ln>
+            <a:noFill/>
+          </a:ln>
+        </p:spPr>
+        <p:style>
+          <a:lnRef idx="1">
+            <a:schemeClr val="accent1"/>
+          </a:lnRef>
+          <a:fillRef idx="3">
+            <a:schemeClr val="accent1"/>
+          </a:fillRef>
+          <a:effectRef idx="2">
+            <a:schemeClr val="accent1"/>
+          </a:effectRef>
+          <a:fontRef idx="minor">
+            <a:schemeClr val="lt1"/>
+          </a:fontRef>
+        </p:style>
+        <p:txBody>
+          <a:bodyPr rtlCol="0" anchor="ctr"/>
+          <a:lstStyle/>
+          <a:p>
+            <a:pPr algn="ctr"/>
+          </a:p>
+        </p:txBody>
+      </p:sp>
+      <p:sp>
+        <p:nvSpPr>
+          <p:cNvPr id="20" name="footer"/>
+          <p:cNvSpPr txBox="1"/>
+          <p:nvPr/>
+        </p:nvSpPr>
+        <p:spPr>
+          <a:xfrm>
+            <a:off x="411480" y="6473952"/>
+            <a:ext cx="11365992" cy="256032"/>
+          </a:xfrm>
+          <a:prstGeom prst="rect">
+            <a:avLst/>
+          </a:prstGeom>
+          <a:noFill/>
+        </p:spPr>
+        <p:txBody>
+          <a:bodyPr wrap="square" anchor="t">
+            <a:spAutoFit/>
+          </a:bodyPr>
+          <a:lstStyle/>
+          <a:p>
+            <a:pPr>
+              <a:spcAft>
+                <a:spcPts val="300"/>
+              </a:spcAft>
+            </a:pPr>
+            <a:r>
+              <a:rPr sz="1000" b="0">
+                <a:solidFill>
+                  <a:srgbClr val="5B6B7C"/>
+                </a:solidFill>
+                <a:latin typeface="Calibri"/>
+              </a:rPr>
+              <a:t>Patterns only - no named HCPs, patient stories, unpublished dossier data  |  5 / 5</a:t>
+            </a:r>
+          </a:p>
+        </p:txBody>
+      </p:sp>
     </p:spTree>
   </p:cSld>
   <p:clrMapOvr>

</xml_diff>